<commit_message>
Add notes to PPT
</commit_message>
<xml_diff>
--- a/slices/Olist_Ecommerce_Project_Presentation.pptx
+++ b/slices/Olist_Ecommerce_Project_Presentation.pptx
@@ -4,6 +4,9 @@
   <p:sldMasterIdLst>
     <p:sldMasterId id="2147483738" r:id="rId1"/>
   </p:sldMasterIdLst>
+  <p:notesMasterIdLst>
+    <p:notesMasterId r:id="rId11"/>
+  </p:notesMasterIdLst>
   <p:sldIdLst>
     <p:sldId id="256" r:id="rId2"/>
     <p:sldId id="257" r:id="rId3"/>
@@ -135,9 +138,1275 @@
 <p1510:revInfo xmlns:a="http://schemas.openxmlformats.org/drawingml/2006/main" xmlns:r="http://schemas.openxmlformats.org/officeDocument/2006/relationships" xmlns:p1510="http://schemas.microsoft.com/office/powerpoint/2015/10/main">
   <p1510:revLst>
     <p1510:client id="{6F752558-1344-4A67-8899-A502F94CDF5C}" v="7" dt="2026-06-07T15:22:03.471"/>
-    <p1510:client id="{E75D47EA-C026-449B-BBAE-3DA48F1C9839}" v="55" dt="2026-06-08T02:00:50.952"/>
+    <p1510:client id="{E75D47EA-C026-449B-BBAE-3DA48F1C9839}" v="192" dt="2026-06-08T07:57:12.641"/>
   </p1510:revLst>
 </p1510:revInfo>
+</file>
+
+<file path=ppt/notesMasters/notesMaster1.xml><?xml version="1.0" encoding="utf-8"?>
+<p:notesMaster xmlns:a="http://schemas.openxmlformats.org/drawingml/2006/main" xmlns:r="http://schemas.openxmlformats.org/officeDocument/2006/relationships" xmlns:p="http://schemas.openxmlformats.org/presentationml/2006/main">
+  <p:cSld>
+    <p:bg>
+      <p:bgRef idx="1001">
+        <a:schemeClr val="bg1"/>
+      </p:bgRef>
+    </p:bg>
+    <p:spTree>
+      <p:nvGrpSpPr>
+        <p:cNvPr id="1" name=""/>
+        <p:cNvGrpSpPr/>
+        <p:nvPr/>
+      </p:nvGrpSpPr>
+      <p:grpSpPr>
+        <a:xfrm>
+          <a:off x="0" y="0"/>
+          <a:ext cx="0" cy="0"/>
+          <a:chOff x="0" y="0"/>
+          <a:chExt cx="0" cy="0"/>
+        </a:xfrm>
+      </p:grpSpPr>
+      <p:sp>
+        <p:nvSpPr>
+          <p:cNvPr id="2" name="Header Placeholder 1"/>
+          <p:cNvSpPr>
+            <a:spLocks noGrp="1"/>
+          </p:cNvSpPr>
+          <p:nvPr>
+            <p:ph type="hdr" sz="quarter"/>
+          </p:nvPr>
+        </p:nvSpPr>
+        <p:spPr>
+          <a:xfrm>
+            <a:off x="0" y="0"/>
+            <a:ext cx="2971800" cy="458788"/>
+          </a:xfrm>
+          <a:prstGeom prst="rect">
+            <a:avLst/>
+          </a:prstGeom>
+        </p:spPr>
+        <p:txBody>
+          <a:bodyPr vert="horz" lIns="91440" tIns="45720" rIns="91440" bIns="45720" rtlCol="0"/>
+          <a:lstStyle>
+            <a:lvl1pPr algn="l">
+              <a:defRPr sz="1200"/>
+            </a:lvl1pPr>
+          </a:lstStyle>
+          <a:p>
+            <a:endParaRPr lang="en-US"/>
+          </a:p>
+        </p:txBody>
+      </p:sp>
+      <p:sp>
+        <p:nvSpPr>
+          <p:cNvPr id="3" name="Date Placeholder 2"/>
+          <p:cNvSpPr>
+            <a:spLocks noGrp="1"/>
+          </p:cNvSpPr>
+          <p:nvPr>
+            <p:ph type="dt" idx="1"/>
+          </p:nvPr>
+        </p:nvSpPr>
+        <p:spPr>
+          <a:xfrm>
+            <a:off x="3884613" y="0"/>
+            <a:ext cx="2971800" cy="458788"/>
+          </a:xfrm>
+          <a:prstGeom prst="rect">
+            <a:avLst/>
+          </a:prstGeom>
+        </p:spPr>
+        <p:txBody>
+          <a:bodyPr vert="horz" lIns="91440" tIns="45720" rIns="91440" bIns="45720" rtlCol="0"/>
+          <a:lstStyle>
+            <a:lvl1pPr algn="r">
+              <a:defRPr sz="1200"/>
+            </a:lvl1pPr>
+          </a:lstStyle>
+          <a:p>
+            <a:fld id="{8DE1E0FE-415D-4A86-A5CB-56FB2301993F}" type="datetimeFigureOut">
+              <a:t>6/8/2026</a:t>
+            </a:fld>
+            <a:endParaRPr lang="en-US"/>
+          </a:p>
+        </p:txBody>
+      </p:sp>
+      <p:sp>
+        <p:nvSpPr>
+          <p:cNvPr id="4" name="Slide Image Placeholder 3"/>
+          <p:cNvSpPr>
+            <a:spLocks noGrp="1" noRot="1" noChangeAspect="1"/>
+          </p:cNvSpPr>
+          <p:nvPr>
+            <p:ph type="sldImg" idx="2"/>
+          </p:nvPr>
+        </p:nvSpPr>
+        <p:spPr>
+          <a:xfrm>
+            <a:off x="1371600" y="1143000"/>
+            <a:ext cx="4114800" cy="3086100"/>
+          </a:xfrm>
+          <a:prstGeom prst="rect">
+            <a:avLst/>
+          </a:prstGeom>
+          <a:noFill/>
+          <a:ln w="12700">
+            <a:solidFill>
+              <a:prstClr val="black"/>
+            </a:solidFill>
+          </a:ln>
+        </p:spPr>
+        <p:txBody>
+          <a:bodyPr vert="horz" lIns="91440" tIns="45720" rIns="91440" bIns="45720" rtlCol="0" anchor="ctr"/>
+          <a:lstStyle/>
+          <a:p>
+            <a:endParaRPr lang="en-US"/>
+          </a:p>
+        </p:txBody>
+      </p:sp>
+      <p:sp>
+        <p:nvSpPr>
+          <p:cNvPr id="5" name="Notes Placeholder 4"/>
+          <p:cNvSpPr>
+            <a:spLocks noGrp="1"/>
+          </p:cNvSpPr>
+          <p:nvPr>
+            <p:ph type="body" sz="quarter" idx="3"/>
+          </p:nvPr>
+        </p:nvSpPr>
+        <p:spPr>
+          <a:xfrm>
+            <a:off x="685800" y="4400550"/>
+            <a:ext cx="5486400" cy="3600450"/>
+          </a:xfrm>
+          <a:prstGeom prst="rect">
+            <a:avLst/>
+          </a:prstGeom>
+        </p:spPr>
+        <p:txBody>
+          <a:bodyPr vert="horz" lIns="91440" tIns="45720" rIns="91440" bIns="45720" rtlCol="0"/>
+          <a:lstStyle/>
+          <a:p>
+            <a:pPr lvl="0"/>
+            <a:r>
+              <a:rPr lang="en-US"/>
+              <a:t>Click to edit Master text styles</a:t>
+            </a:r>
+          </a:p>
+          <a:p>
+            <a:pPr lvl="1"/>
+            <a:r>
+              <a:rPr lang="en-US"/>
+              <a:t>Second level</a:t>
+            </a:r>
+          </a:p>
+          <a:p>
+            <a:pPr lvl="2"/>
+            <a:r>
+              <a:rPr lang="en-US"/>
+              <a:t>Third level</a:t>
+            </a:r>
+          </a:p>
+          <a:p>
+            <a:pPr lvl="3"/>
+            <a:r>
+              <a:rPr lang="en-US"/>
+              <a:t>Fourth level</a:t>
+            </a:r>
+          </a:p>
+          <a:p>
+            <a:pPr lvl="4"/>
+            <a:r>
+              <a:rPr lang="en-US"/>
+              <a:t>Fifth level</a:t>
+            </a:r>
+          </a:p>
+        </p:txBody>
+      </p:sp>
+      <p:sp>
+        <p:nvSpPr>
+          <p:cNvPr id="6" name="Footer Placeholder 5"/>
+          <p:cNvSpPr>
+            <a:spLocks noGrp="1"/>
+          </p:cNvSpPr>
+          <p:nvPr>
+            <p:ph type="ftr" sz="quarter" idx="4"/>
+          </p:nvPr>
+        </p:nvSpPr>
+        <p:spPr>
+          <a:xfrm>
+            <a:off x="0" y="8685213"/>
+            <a:ext cx="2971800" cy="458787"/>
+          </a:xfrm>
+          <a:prstGeom prst="rect">
+            <a:avLst/>
+          </a:prstGeom>
+        </p:spPr>
+        <p:txBody>
+          <a:bodyPr vert="horz" lIns="91440" tIns="45720" rIns="91440" bIns="45720" rtlCol="0" anchor="b"/>
+          <a:lstStyle>
+            <a:lvl1pPr algn="l">
+              <a:defRPr sz="1200"/>
+            </a:lvl1pPr>
+          </a:lstStyle>
+          <a:p>
+            <a:endParaRPr lang="en-US"/>
+          </a:p>
+        </p:txBody>
+      </p:sp>
+      <p:sp>
+        <p:nvSpPr>
+          <p:cNvPr id="7" name="Slide Number Placeholder 6"/>
+          <p:cNvSpPr>
+            <a:spLocks noGrp="1"/>
+          </p:cNvSpPr>
+          <p:nvPr>
+            <p:ph type="sldNum" sz="quarter" idx="5"/>
+          </p:nvPr>
+        </p:nvSpPr>
+        <p:spPr>
+          <a:xfrm>
+            <a:off x="3884613" y="8685213"/>
+            <a:ext cx="2971800" cy="458787"/>
+          </a:xfrm>
+          <a:prstGeom prst="rect">
+            <a:avLst/>
+          </a:prstGeom>
+        </p:spPr>
+        <p:txBody>
+          <a:bodyPr vert="horz" lIns="91440" tIns="45720" rIns="91440" bIns="45720" rtlCol="0" anchor="b"/>
+          <a:lstStyle>
+            <a:lvl1pPr algn="r">
+              <a:defRPr sz="1200"/>
+            </a:lvl1pPr>
+          </a:lstStyle>
+          <a:p>
+            <a:fld id="{BB5C6805-D20B-405F-86DA-DC495A4FC83C}" type="slidenum">
+              <a:t>‹#›</a:t>
+            </a:fld>
+            <a:endParaRPr lang="en-US"/>
+          </a:p>
+        </p:txBody>
+      </p:sp>
+    </p:spTree>
+    <p:extLst>
+      <p:ext uri="{BB962C8B-B14F-4D97-AF65-F5344CB8AC3E}">
+        <p14:creationId xmlns:p14="http://schemas.microsoft.com/office/powerpoint/2010/main" val="3213445057"/>
+      </p:ext>
+    </p:extLst>
+  </p:cSld>
+  <p:clrMap bg1="lt1" tx1="dk1" bg2="lt2" tx2="dk2" accent1="accent1" accent2="accent2" accent3="accent3" accent4="accent4" accent5="accent5" accent6="accent6" hlink="hlink" folHlink="folHlink"/>
+  <p:notesStyle>
+    <a:lvl1pPr marL="0" algn="l" defTabSz="914400" rtl="0" eaLnBrk="1" latinLnBrk="0" hangingPunct="1">
+      <a:defRPr sz="1200" kern="1200">
+        <a:solidFill>
+          <a:schemeClr val="tx1"/>
+        </a:solidFill>
+        <a:latin typeface="+mn-lt"/>
+        <a:ea typeface="+mn-ea"/>
+        <a:cs typeface="+mn-cs"/>
+      </a:defRPr>
+    </a:lvl1pPr>
+    <a:lvl2pPr marL="457200" algn="l" defTabSz="914400" rtl="0" eaLnBrk="1" latinLnBrk="0" hangingPunct="1">
+      <a:defRPr sz="1200" kern="1200">
+        <a:solidFill>
+          <a:schemeClr val="tx1"/>
+        </a:solidFill>
+        <a:latin typeface="+mn-lt"/>
+        <a:ea typeface="+mn-ea"/>
+        <a:cs typeface="+mn-cs"/>
+      </a:defRPr>
+    </a:lvl2pPr>
+    <a:lvl3pPr marL="914400" algn="l" defTabSz="914400" rtl="0" eaLnBrk="1" latinLnBrk="0" hangingPunct="1">
+      <a:defRPr sz="1200" kern="1200">
+        <a:solidFill>
+          <a:schemeClr val="tx1"/>
+        </a:solidFill>
+        <a:latin typeface="+mn-lt"/>
+        <a:ea typeface="+mn-ea"/>
+        <a:cs typeface="+mn-cs"/>
+      </a:defRPr>
+    </a:lvl3pPr>
+    <a:lvl4pPr marL="1371600" algn="l" defTabSz="914400" rtl="0" eaLnBrk="1" latinLnBrk="0" hangingPunct="1">
+      <a:defRPr sz="1200" kern="1200">
+        <a:solidFill>
+          <a:schemeClr val="tx1"/>
+        </a:solidFill>
+        <a:latin typeface="+mn-lt"/>
+        <a:ea typeface="+mn-ea"/>
+        <a:cs typeface="+mn-cs"/>
+      </a:defRPr>
+    </a:lvl4pPr>
+    <a:lvl5pPr marL="1828800" algn="l" defTabSz="914400" rtl="0" eaLnBrk="1" latinLnBrk="0" hangingPunct="1">
+      <a:defRPr sz="1200" kern="1200">
+        <a:solidFill>
+          <a:schemeClr val="tx1"/>
+        </a:solidFill>
+        <a:latin typeface="+mn-lt"/>
+        <a:ea typeface="+mn-ea"/>
+        <a:cs typeface="+mn-cs"/>
+      </a:defRPr>
+    </a:lvl5pPr>
+    <a:lvl6pPr marL="2286000" algn="l" defTabSz="914400" rtl="0" eaLnBrk="1" latinLnBrk="0" hangingPunct="1">
+      <a:defRPr sz="1200" kern="1200">
+        <a:solidFill>
+          <a:schemeClr val="tx1"/>
+        </a:solidFill>
+        <a:latin typeface="+mn-lt"/>
+        <a:ea typeface="+mn-ea"/>
+        <a:cs typeface="+mn-cs"/>
+      </a:defRPr>
+    </a:lvl6pPr>
+    <a:lvl7pPr marL="2743200" algn="l" defTabSz="914400" rtl="0" eaLnBrk="1" latinLnBrk="0" hangingPunct="1">
+      <a:defRPr sz="1200" kern="1200">
+        <a:solidFill>
+          <a:schemeClr val="tx1"/>
+        </a:solidFill>
+        <a:latin typeface="+mn-lt"/>
+        <a:ea typeface="+mn-ea"/>
+        <a:cs typeface="+mn-cs"/>
+      </a:defRPr>
+    </a:lvl7pPr>
+    <a:lvl8pPr marL="3200400" algn="l" defTabSz="914400" rtl="0" eaLnBrk="1" latinLnBrk="0" hangingPunct="1">
+      <a:defRPr sz="1200" kern="1200">
+        <a:solidFill>
+          <a:schemeClr val="tx1"/>
+        </a:solidFill>
+        <a:latin typeface="+mn-lt"/>
+        <a:ea typeface="+mn-ea"/>
+        <a:cs typeface="+mn-cs"/>
+      </a:defRPr>
+    </a:lvl8pPr>
+    <a:lvl9pPr marL="3657600" algn="l" defTabSz="914400" rtl="0" eaLnBrk="1" latinLnBrk="0" hangingPunct="1">
+      <a:defRPr sz="1200" kern="1200">
+        <a:solidFill>
+          <a:schemeClr val="tx1"/>
+        </a:solidFill>
+        <a:latin typeface="+mn-lt"/>
+        <a:ea typeface="+mn-ea"/>
+        <a:cs typeface="+mn-cs"/>
+      </a:defRPr>
+    </a:lvl9pPr>
+  </p:notesStyle>
+</p:notesMaster>
+</file>
+
+<file path=ppt/notesSlides/notesSlide1.xml><?xml version="1.0" encoding="utf-8"?>
+<p:notes xmlns:a="http://schemas.openxmlformats.org/drawingml/2006/main" xmlns:r="http://schemas.openxmlformats.org/officeDocument/2006/relationships" xmlns:p="http://schemas.openxmlformats.org/presentationml/2006/main">
+  <p:cSld>
+    <p:spTree>
+      <p:nvGrpSpPr>
+        <p:cNvPr id="1" name=""/>
+        <p:cNvGrpSpPr/>
+        <p:nvPr/>
+      </p:nvGrpSpPr>
+      <p:grpSpPr>
+        <a:xfrm>
+          <a:off x="0" y="0"/>
+          <a:ext cx="0" cy="0"/>
+          <a:chOff x="0" y="0"/>
+          <a:chExt cx="0" cy="0"/>
+        </a:xfrm>
+      </p:grpSpPr>
+      <p:sp>
+        <p:nvSpPr>
+          <p:cNvPr id="2" name="Slide Image Placeholder 1"/>
+          <p:cNvSpPr>
+            <a:spLocks noGrp="1" noRot="1" noChangeAspect="1"/>
+          </p:cNvSpPr>
+          <p:nvPr>
+            <p:ph type="sldImg"/>
+          </p:nvPr>
+        </p:nvSpPr>
+        <p:spPr/>
+      </p:sp>
+      <p:sp>
+        <p:nvSpPr>
+          <p:cNvPr id="3" name="Notes Placeholder 2"/>
+          <p:cNvSpPr>
+            <a:spLocks noGrp="1"/>
+          </p:cNvSpPr>
+          <p:nvPr>
+            <p:ph type="body" idx="1"/>
+          </p:nvPr>
+        </p:nvSpPr>
+        <p:spPr/>
+        <p:txBody>
+          <a:bodyPr/>
+          <a:lstStyle/>
+          <a:p>
+            <a:r>
+              <a:rPr lang="en-US" dirty="0"/>
+              <a:t>Huang Wei: Our project analyzes the Brazilian E-Commerce Public Dataset by </a:t>
+            </a:r>
+            <a:r>
+              <a:rPr lang="en-US" dirty="0" err="1"/>
+              <a:t>Olist</a:t>
+            </a:r>
+            <a:r>
+              <a:rPr lang="en-US" dirty="0"/>
+              <a:t>. The goal was to build an end-to-end analytics workflow: load raw data into </a:t>
+            </a:r>
+            <a:r>
+              <a:rPr lang="en-US" dirty="0" err="1"/>
+              <a:t>DuckDB</a:t>
+            </a:r>
+            <a:r>
+              <a:rPr lang="en-US" dirty="0"/>
+              <a:t>, model it into a star schema using </a:t>
+            </a:r>
+            <a:r>
+              <a:rPr lang="en-US" dirty="0" err="1"/>
+              <a:t>dbt</a:t>
+            </a:r>
+            <a:r>
+              <a:rPr lang="en-US" dirty="0"/>
+              <a:t>, validate data quality with </a:t>
+            </a:r>
+            <a:r>
+              <a:rPr lang="en-US" dirty="0" err="1"/>
+              <a:t>dbt</a:t>
+            </a:r>
+            <a:r>
+              <a:rPr lang="en-US" dirty="0"/>
+              <a:t> tests, and then perform business analysis and visualization with Python and Pandas.</a:t>
+            </a:r>
+          </a:p>
+        </p:txBody>
+      </p:sp>
+      <p:sp>
+        <p:nvSpPr>
+          <p:cNvPr id="4" name="Slide Number Placeholder 3"/>
+          <p:cNvSpPr>
+            <a:spLocks noGrp="1"/>
+          </p:cNvSpPr>
+          <p:nvPr>
+            <p:ph type="sldNum" sz="quarter" idx="5"/>
+          </p:nvPr>
+        </p:nvSpPr>
+        <p:spPr/>
+        <p:txBody>
+          <a:bodyPr/>
+          <a:lstStyle/>
+          <a:p>
+            <a:fld id="{BB5C6805-D20B-405F-86DA-DC495A4FC83C}" type="slidenum">
+              <a:rPr lang="en-US"/>
+              <a:t>1</a:t>
+            </a:fld>
+            <a:endParaRPr lang="en-US"/>
+          </a:p>
+        </p:txBody>
+      </p:sp>
+    </p:spTree>
+    <p:extLst>
+      <p:ext uri="{BB962C8B-B14F-4D97-AF65-F5344CB8AC3E}">
+        <p14:creationId xmlns:p14="http://schemas.microsoft.com/office/powerpoint/2010/main" val="989305360"/>
+      </p:ext>
+    </p:extLst>
+  </p:cSld>
+  <p:clrMapOvr>
+    <a:masterClrMapping/>
+  </p:clrMapOvr>
+</p:notes>
+</file>
+
+<file path=ppt/notesSlides/notesSlide2.xml><?xml version="1.0" encoding="utf-8"?>
+<p:notes xmlns:a="http://schemas.openxmlformats.org/drawingml/2006/main" xmlns:r="http://schemas.openxmlformats.org/officeDocument/2006/relationships" xmlns:p="http://schemas.openxmlformats.org/presentationml/2006/main">
+  <p:cSld>
+    <p:spTree>
+      <p:nvGrpSpPr>
+        <p:cNvPr id="1" name=""/>
+        <p:cNvGrpSpPr/>
+        <p:nvPr/>
+      </p:nvGrpSpPr>
+      <p:grpSpPr>
+        <a:xfrm>
+          <a:off x="0" y="0"/>
+          <a:ext cx="0" cy="0"/>
+          <a:chOff x="0" y="0"/>
+          <a:chExt cx="0" cy="0"/>
+        </a:xfrm>
+      </p:grpSpPr>
+      <p:sp>
+        <p:nvSpPr>
+          <p:cNvPr id="2" name="Slide Image Placeholder 1"/>
+          <p:cNvSpPr>
+            <a:spLocks noGrp="1" noRot="1" noChangeAspect="1"/>
+          </p:cNvSpPr>
+          <p:nvPr>
+            <p:ph type="sldImg"/>
+          </p:nvPr>
+        </p:nvSpPr>
+        <p:spPr/>
+      </p:sp>
+      <p:sp>
+        <p:nvSpPr>
+          <p:cNvPr id="3" name="Notes Placeholder 2"/>
+          <p:cNvSpPr>
+            <a:spLocks noGrp="1"/>
+          </p:cNvSpPr>
+          <p:nvPr>
+            <p:ph type="body" idx="1"/>
+          </p:nvPr>
+        </p:nvSpPr>
+        <p:spPr/>
+        <p:txBody>
+          <a:bodyPr/>
+          <a:lstStyle/>
+          <a:p>
+            <a:r>
+              <a:rPr lang="en-US" dirty="0"/>
+              <a:t>Huang Wei: The workflow starts with CSV files from the </a:t>
+            </a:r>
+            <a:r>
+              <a:rPr lang="en-US" dirty="0" err="1"/>
+              <a:t>Olist</a:t>
+            </a:r>
+            <a:r>
+              <a:rPr lang="en-US" dirty="0"/>
+              <a:t> dataset. We loaded them into </a:t>
+            </a:r>
+            <a:r>
+              <a:rPr lang="en-US" dirty="0" err="1"/>
+              <a:t>DuckDB</a:t>
+            </a:r>
+            <a:r>
+              <a:rPr lang="en-US" dirty="0"/>
+              <a:t>, then used </a:t>
+            </a:r>
+            <a:r>
+              <a:rPr lang="en-US" dirty="0" err="1"/>
+              <a:t>dbt</a:t>
+            </a:r>
+            <a:r>
+              <a:rPr lang="en-US" dirty="0"/>
+              <a:t> to create staging models and dimensional warehouse tables. After validating the data with </a:t>
+            </a:r>
+            <a:r>
+              <a:rPr lang="en-US" dirty="0" err="1"/>
+              <a:t>dbt</a:t>
+            </a:r>
+            <a:r>
+              <a:rPr lang="en-US" dirty="0"/>
+              <a:t> tests, We used Pandas and Matplotlib to generate business insights and charts. We selected </a:t>
+            </a:r>
+            <a:r>
+              <a:rPr lang="en-US" dirty="0" err="1"/>
+              <a:t>DuckDB</a:t>
+            </a:r>
+            <a:r>
+              <a:rPr lang="en-US" dirty="0"/>
+              <a:t> as our analytical database because it can work directly with CSV files, and it is fully supported by </a:t>
+            </a:r>
+            <a:r>
+              <a:rPr lang="en-US" dirty="0" err="1"/>
+              <a:t>dbt</a:t>
+            </a:r>
+            <a:r>
+              <a:rPr lang="en-US" dirty="0"/>
+              <a:t>.</a:t>
+            </a:r>
+            <a:endParaRPr lang="en-US"/>
+          </a:p>
+        </p:txBody>
+      </p:sp>
+      <p:sp>
+        <p:nvSpPr>
+          <p:cNvPr id="4" name="Slide Number Placeholder 3"/>
+          <p:cNvSpPr>
+            <a:spLocks noGrp="1"/>
+          </p:cNvSpPr>
+          <p:nvPr>
+            <p:ph type="sldNum" sz="quarter" idx="5"/>
+          </p:nvPr>
+        </p:nvSpPr>
+        <p:spPr/>
+        <p:txBody>
+          <a:bodyPr/>
+          <a:lstStyle/>
+          <a:p>
+            <a:fld id="{BB5C6805-D20B-405F-86DA-DC495A4FC83C}" type="slidenum">
+              <a:t>2</a:t>
+            </a:fld>
+            <a:endParaRPr lang="en-US"/>
+          </a:p>
+        </p:txBody>
+      </p:sp>
+    </p:spTree>
+    <p:extLst>
+      <p:ext uri="{BB962C8B-B14F-4D97-AF65-F5344CB8AC3E}">
+        <p14:creationId xmlns:p14="http://schemas.microsoft.com/office/powerpoint/2010/main" val="929460200"/>
+      </p:ext>
+    </p:extLst>
+  </p:cSld>
+  <p:clrMapOvr>
+    <a:masterClrMapping/>
+  </p:clrMapOvr>
+</p:notes>
+</file>
+
+<file path=ppt/notesSlides/notesSlide3.xml><?xml version="1.0" encoding="utf-8"?>
+<p:notes xmlns:a="http://schemas.openxmlformats.org/drawingml/2006/main" xmlns:r="http://schemas.openxmlformats.org/officeDocument/2006/relationships" xmlns:p="http://schemas.openxmlformats.org/presentationml/2006/main">
+  <p:cSld>
+    <p:spTree>
+      <p:nvGrpSpPr>
+        <p:cNvPr id="1" name=""/>
+        <p:cNvGrpSpPr/>
+        <p:nvPr/>
+      </p:nvGrpSpPr>
+      <p:grpSpPr>
+        <a:xfrm>
+          <a:off x="0" y="0"/>
+          <a:ext cx="0" cy="0"/>
+          <a:chOff x="0" y="0"/>
+          <a:chExt cx="0" cy="0"/>
+        </a:xfrm>
+      </p:grpSpPr>
+      <p:sp>
+        <p:nvSpPr>
+          <p:cNvPr id="2" name="Slide Image Placeholder 1"/>
+          <p:cNvSpPr>
+            <a:spLocks noGrp="1" noRot="1" noChangeAspect="1"/>
+          </p:cNvSpPr>
+          <p:nvPr>
+            <p:ph type="sldImg"/>
+          </p:nvPr>
+        </p:nvSpPr>
+        <p:spPr/>
+      </p:sp>
+      <p:sp>
+        <p:nvSpPr>
+          <p:cNvPr id="3" name="Notes Placeholder 2"/>
+          <p:cNvSpPr>
+            <a:spLocks noGrp="1"/>
+          </p:cNvSpPr>
+          <p:nvPr>
+            <p:ph type="body" idx="1"/>
+          </p:nvPr>
+        </p:nvSpPr>
+        <p:spPr/>
+        <p:txBody>
+          <a:bodyPr/>
+          <a:lstStyle/>
+          <a:p>
+            <a:r>
+              <a:rPr lang="en-US" dirty="0"/>
+              <a:t>The warehouse uses a star schema. The central fact table is </a:t>
+            </a:r>
+            <a:r>
+              <a:rPr lang="en-US" dirty="0" err="1"/>
+              <a:t>fact_sales</a:t>
+            </a:r>
+            <a:r>
+              <a:rPr lang="en-US" dirty="0"/>
+              <a:t>, which contains transaction-level sales data. Around it are three dimensions: </a:t>
+            </a:r>
+            <a:r>
+              <a:rPr lang="en-US" dirty="0" err="1"/>
+              <a:t>dim_customer</a:t>
+            </a:r>
+            <a:r>
+              <a:rPr lang="en-US" dirty="0"/>
+              <a:t>, </a:t>
+            </a:r>
+            <a:r>
+              <a:rPr lang="en-US" dirty="0" err="1"/>
+              <a:t>dim_product</a:t>
+            </a:r>
+            <a:r>
+              <a:rPr lang="en-US" dirty="0"/>
+              <a:t>, and </a:t>
+            </a:r>
+            <a:r>
+              <a:rPr lang="en-US" dirty="0" err="1"/>
+              <a:t>dim_seller</a:t>
+            </a:r>
+            <a:r>
+              <a:rPr lang="en-US" dirty="0"/>
+              <a:t>. This structure simplifies analytical queries and reporting.</a:t>
+            </a:r>
+          </a:p>
+        </p:txBody>
+      </p:sp>
+      <p:sp>
+        <p:nvSpPr>
+          <p:cNvPr id="4" name="Slide Number Placeholder 3"/>
+          <p:cNvSpPr>
+            <a:spLocks noGrp="1"/>
+          </p:cNvSpPr>
+          <p:nvPr>
+            <p:ph type="sldNum" sz="quarter" idx="5"/>
+          </p:nvPr>
+        </p:nvSpPr>
+        <p:spPr/>
+        <p:txBody>
+          <a:bodyPr/>
+          <a:lstStyle/>
+          <a:p>
+            <a:fld id="{BB5C6805-D20B-405F-86DA-DC495A4FC83C}" type="slidenum">
+              <a:rPr lang="en-US"/>
+              <a:t>3</a:t>
+            </a:fld>
+            <a:endParaRPr lang="en-US"/>
+          </a:p>
+        </p:txBody>
+      </p:sp>
+    </p:spTree>
+    <p:extLst>
+      <p:ext uri="{BB962C8B-B14F-4D97-AF65-F5344CB8AC3E}">
+        <p14:creationId xmlns:p14="http://schemas.microsoft.com/office/powerpoint/2010/main" val="2466823994"/>
+      </p:ext>
+    </p:extLst>
+  </p:cSld>
+  <p:clrMapOvr>
+    <a:masterClrMapping/>
+  </p:clrMapOvr>
+</p:notes>
+</file>
+
+<file path=ppt/notesSlides/notesSlide4.xml><?xml version="1.0" encoding="utf-8"?>
+<p:notes xmlns:a="http://schemas.openxmlformats.org/drawingml/2006/main" xmlns:r="http://schemas.openxmlformats.org/officeDocument/2006/relationships" xmlns:p="http://schemas.openxmlformats.org/presentationml/2006/main">
+  <p:cSld>
+    <p:spTree>
+      <p:nvGrpSpPr>
+        <p:cNvPr id="1" name=""/>
+        <p:cNvGrpSpPr/>
+        <p:nvPr/>
+      </p:nvGrpSpPr>
+      <p:grpSpPr>
+        <a:xfrm>
+          <a:off x="0" y="0"/>
+          <a:ext cx="0" cy="0"/>
+          <a:chOff x="0" y="0"/>
+          <a:chExt cx="0" cy="0"/>
+        </a:xfrm>
+      </p:grpSpPr>
+      <p:sp>
+        <p:nvSpPr>
+          <p:cNvPr id="2" name="Slide Image Placeholder 1"/>
+          <p:cNvSpPr>
+            <a:spLocks noGrp="1" noRot="1" noChangeAspect="1"/>
+          </p:cNvSpPr>
+          <p:nvPr>
+            <p:ph type="sldImg"/>
+          </p:nvPr>
+        </p:nvSpPr>
+        <p:spPr/>
+      </p:sp>
+      <p:sp>
+        <p:nvSpPr>
+          <p:cNvPr id="3" name="Notes Placeholder 2"/>
+          <p:cNvSpPr>
+            <a:spLocks noGrp="1"/>
+          </p:cNvSpPr>
+          <p:nvPr>
+            <p:ph type="body" idx="1"/>
+          </p:nvPr>
+        </p:nvSpPr>
+        <p:spPr/>
+        <p:txBody>
+          <a:bodyPr/>
+          <a:lstStyle/>
+          <a:p>
+            <a:r>
+              <a:rPr lang="en-US" dirty="0"/>
+              <a:t>We added </a:t>
+            </a:r>
+            <a:r>
+              <a:rPr lang="en-US" dirty="0" err="1"/>
+              <a:t>dbt</a:t>
+            </a:r>
+            <a:r>
+              <a:rPr lang="en-US" dirty="0"/>
+              <a:t> tests to ensure key fields are reliable. The tests checked that customer, product, and seller IDs are unique and not null, and that sales records contain valid order IDs. All seven tests passed successfully, which gave us confidence that the warehouse was consistent before running analysis.</a:t>
+            </a:r>
+          </a:p>
+        </p:txBody>
+      </p:sp>
+      <p:sp>
+        <p:nvSpPr>
+          <p:cNvPr id="4" name="Slide Number Placeholder 3"/>
+          <p:cNvSpPr>
+            <a:spLocks noGrp="1"/>
+          </p:cNvSpPr>
+          <p:nvPr>
+            <p:ph type="sldNum" sz="quarter" idx="5"/>
+          </p:nvPr>
+        </p:nvSpPr>
+        <p:spPr/>
+        <p:txBody>
+          <a:bodyPr/>
+          <a:lstStyle/>
+          <a:p>
+            <a:fld id="{BB5C6805-D20B-405F-86DA-DC495A4FC83C}" type="slidenum">
+              <a:rPr lang="en-US"/>
+              <a:t>4</a:t>
+            </a:fld>
+            <a:endParaRPr lang="en-US"/>
+          </a:p>
+        </p:txBody>
+      </p:sp>
+    </p:spTree>
+    <p:extLst>
+      <p:ext uri="{BB962C8B-B14F-4D97-AF65-F5344CB8AC3E}">
+        <p14:creationId xmlns:p14="http://schemas.microsoft.com/office/powerpoint/2010/main" val="107882301"/>
+      </p:ext>
+    </p:extLst>
+  </p:cSld>
+  <p:clrMapOvr>
+    <a:masterClrMapping/>
+  </p:clrMapOvr>
+</p:notes>
+</file>
+
+<file path=ppt/notesSlides/notesSlide5.xml><?xml version="1.0" encoding="utf-8"?>
+<p:notes xmlns:a="http://schemas.openxmlformats.org/drawingml/2006/main" xmlns:r="http://schemas.openxmlformats.org/officeDocument/2006/relationships" xmlns:p="http://schemas.openxmlformats.org/presentationml/2006/main">
+  <p:cSld>
+    <p:spTree>
+      <p:nvGrpSpPr>
+        <p:cNvPr id="1" name=""/>
+        <p:cNvGrpSpPr/>
+        <p:nvPr/>
+      </p:nvGrpSpPr>
+      <p:grpSpPr>
+        <a:xfrm>
+          <a:off x="0" y="0"/>
+          <a:ext cx="0" cy="0"/>
+          <a:chOff x="0" y="0"/>
+          <a:chExt cx="0" cy="0"/>
+        </a:xfrm>
+      </p:grpSpPr>
+      <p:sp>
+        <p:nvSpPr>
+          <p:cNvPr id="2" name="Slide Image Placeholder 1"/>
+          <p:cNvSpPr>
+            <a:spLocks noGrp="1" noRot="1" noChangeAspect="1"/>
+          </p:cNvSpPr>
+          <p:nvPr>
+            <p:ph type="sldImg"/>
+          </p:nvPr>
+        </p:nvSpPr>
+        <p:spPr/>
+      </p:sp>
+      <p:sp>
+        <p:nvSpPr>
+          <p:cNvPr id="3" name="Notes Placeholder 2"/>
+          <p:cNvSpPr>
+            <a:spLocks noGrp="1"/>
+          </p:cNvSpPr>
+          <p:nvPr>
+            <p:ph type="body" idx="1"/>
+          </p:nvPr>
+        </p:nvSpPr>
+        <p:spPr/>
+        <p:txBody>
+          <a:bodyPr/>
+          <a:lstStyle/>
+          <a:p>
+            <a:r>
+              <a:rPr lang="en-US" dirty="0"/>
+              <a:t>This chart shows monthly revenue over time. Revenue generally increased during 2017 and 2018, indicating significant growth in the platform during the observed period. The trend also shows seasonal fluctuations, which are common in e-commerce businesses.</a:t>
+            </a:r>
+          </a:p>
+        </p:txBody>
+      </p:sp>
+      <p:sp>
+        <p:nvSpPr>
+          <p:cNvPr id="4" name="Slide Number Placeholder 3"/>
+          <p:cNvSpPr>
+            <a:spLocks noGrp="1"/>
+          </p:cNvSpPr>
+          <p:nvPr>
+            <p:ph type="sldNum" sz="quarter" idx="5"/>
+          </p:nvPr>
+        </p:nvSpPr>
+        <p:spPr/>
+        <p:txBody>
+          <a:bodyPr/>
+          <a:lstStyle/>
+          <a:p>
+            <a:fld id="{BB5C6805-D20B-405F-86DA-DC495A4FC83C}" type="slidenum">
+              <a:rPr lang="en-US"/>
+              <a:t>5</a:t>
+            </a:fld>
+            <a:endParaRPr lang="en-US"/>
+          </a:p>
+        </p:txBody>
+      </p:sp>
+    </p:spTree>
+    <p:extLst>
+      <p:ext uri="{BB962C8B-B14F-4D97-AF65-F5344CB8AC3E}">
+        <p14:creationId xmlns:p14="http://schemas.microsoft.com/office/powerpoint/2010/main" val="1004333252"/>
+      </p:ext>
+    </p:extLst>
+  </p:cSld>
+  <p:clrMapOvr>
+    <a:masterClrMapping/>
+  </p:clrMapOvr>
+</p:notes>
+</file>
+
+<file path=ppt/notesSlides/notesSlide6.xml><?xml version="1.0" encoding="utf-8"?>
+<p:notes xmlns:a="http://schemas.openxmlformats.org/drawingml/2006/main" xmlns:r="http://schemas.openxmlformats.org/officeDocument/2006/relationships" xmlns:p="http://schemas.openxmlformats.org/presentationml/2006/main">
+  <p:cSld>
+    <p:spTree>
+      <p:nvGrpSpPr>
+        <p:cNvPr id="1" name=""/>
+        <p:cNvGrpSpPr/>
+        <p:nvPr/>
+      </p:nvGrpSpPr>
+      <p:grpSpPr>
+        <a:xfrm>
+          <a:off x="0" y="0"/>
+          <a:ext cx="0" cy="0"/>
+          <a:chOff x="0" y="0"/>
+          <a:chExt cx="0" cy="0"/>
+        </a:xfrm>
+      </p:grpSpPr>
+      <p:sp>
+        <p:nvSpPr>
+          <p:cNvPr id="2" name="Slide Image Placeholder 1"/>
+          <p:cNvSpPr>
+            <a:spLocks noGrp="1" noRot="1" noChangeAspect="1"/>
+          </p:cNvSpPr>
+          <p:nvPr>
+            <p:ph type="sldImg"/>
+          </p:nvPr>
+        </p:nvSpPr>
+        <p:spPr/>
+      </p:sp>
+      <p:sp>
+        <p:nvSpPr>
+          <p:cNvPr id="3" name="Notes Placeholder 2"/>
+          <p:cNvSpPr>
+            <a:spLocks noGrp="1"/>
+          </p:cNvSpPr>
+          <p:nvPr>
+            <p:ph type="body" idx="1"/>
+          </p:nvPr>
+        </p:nvSpPr>
+        <p:spPr/>
+        <p:txBody>
+          <a:bodyPr/>
+          <a:lstStyle/>
+          <a:p>
+            <a:r>
+              <a:rPr lang="en-US"/>
+              <a:t>The highest-revenue product categories were Beauty &amp; Health, Watches &amp; Gifts, and Bed, Bath &amp; Table. These categories contributed a large share of total revenue and could be prioritized for marketing and inventory planning.</a:t>
+            </a:r>
+          </a:p>
+        </p:txBody>
+      </p:sp>
+      <p:sp>
+        <p:nvSpPr>
+          <p:cNvPr id="4" name="Slide Number Placeholder 3"/>
+          <p:cNvSpPr>
+            <a:spLocks noGrp="1"/>
+          </p:cNvSpPr>
+          <p:nvPr>
+            <p:ph type="sldNum" sz="quarter" idx="5"/>
+          </p:nvPr>
+        </p:nvSpPr>
+        <p:spPr/>
+        <p:txBody>
+          <a:bodyPr/>
+          <a:lstStyle/>
+          <a:p>
+            <a:fld id="{BB5C6805-D20B-405F-86DA-DC495A4FC83C}" type="slidenum">
+              <a:rPr lang="en-US"/>
+              <a:t>6</a:t>
+            </a:fld>
+            <a:endParaRPr lang="en-US"/>
+          </a:p>
+        </p:txBody>
+      </p:sp>
+    </p:spTree>
+    <p:extLst>
+      <p:ext uri="{BB962C8B-B14F-4D97-AF65-F5344CB8AC3E}">
+        <p14:creationId xmlns:p14="http://schemas.microsoft.com/office/powerpoint/2010/main" val="2649634372"/>
+      </p:ext>
+    </p:extLst>
+  </p:cSld>
+  <p:clrMapOvr>
+    <a:masterClrMapping/>
+  </p:clrMapOvr>
+</p:notes>
+</file>
+
+<file path=ppt/notesSlides/notesSlide7.xml><?xml version="1.0" encoding="utf-8"?>
+<p:notes xmlns:a="http://schemas.openxmlformats.org/drawingml/2006/main" xmlns:r="http://schemas.openxmlformats.org/officeDocument/2006/relationships" xmlns:p="http://schemas.openxmlformats.org/presentationml/2006/main">
+  <p:cSld>
+    <p:spTree>
+      <p:nvGrpSpPr>
+        <p:cNvPr id="1" name=""/>
+        <p:cNvGrpSpPr/>
+        <p:nvPr/>
+      </p:nvGrpSpPr>
+      <p:grpSpPr>
+        <a:xfrm>
+          <a:off x="0" y="0"/>
+          <a:ext cx="0" cy="0"/>
+          <a:chOff x="0" y="0"/>
+          <a:chExt cx="0" cy="0"/>
+        </a:xfrm>
+      </p:grpSpPr>
+      <p:sp>
+        <p:nvSpPr>
+          <p:cNvPr id="2" name="Slide Image Placeholder 1"/>
+          <p:cNvSpPr>
+            <a:spLocks noGrp="1" noRot="1" noChangeAspect="1"/>
+          </p:cNvSpPr>
+          <p:nvPr>
+            <p:ph type="sldImg"/>
+          </p:nvPr>
+        </p:nvSpPr>
+        <p:spPr/>
+      </p:sp>
+      <p:sp>
+        <p:nvSpPr>
+          <p:cNvPr id="3" name="Notes Placeholder 2"/>
+          <p:cNvSpPr>
+            <a:spLocks noGrp="1"/>
+          </p:cNvSpPr>
+          <p:nvPr>
+            <p:ph type="body" idx="1"/>
+          </p:nvPr>
+        </p:nvSpPr>
+        <p:spPr/>
+        <p:txBody>
+          <a:bodyPr/>
+          <a:lstStyle/>
+          <a:p>
+            <a:r>
+              <a:rPr lang="en-US"/>
+              <a:t>Revenue was heavily concentrated in São Paulo (SP), followed by Rio de Janeiro and Minas Gerais. This suggests that customer demand is strongest in Brazil’s largest economic regions.</a:t>
+            </a:r>
+          </a:p>
+        </p:txBody>
+      </p:sp>
+      <p:sp>
+        <p:nvSpPr>
+          <p:cNvPr id="4" name="Slide Number Placeholder 3"/>
+          <p:cNvSpPr>
+            <a:spLocks noGrp="1"/>
+          </p:cNvSpPr>
+          <p:nvPr>
+            <p:ph type="sldNum" sz="quarter" idx="5"/>
+          </p:nvPr>
+        </p:nvSpPr>
+        <p:spPr/>
+        <p:txBody>
+          <a:bodyPr/>
+          <a:lstStyle/>
+          <a:p>
+            <a:fld id="{BB5C6805-D20B-405F-86DA-DC495A4FC83C}" type="slidenum">
+              <a:rPr lang="en-US"/>
+              <a:t>7</a:t>
+            </a:fld>
+            <a:endParaRPr lang="en-US"/>
+          </a:p>
+        </p:txBody>
+      </p:sp>
+    </p:spTree>
+    <p:extLst>
+      <p:ext uri="{BB962C8B-B14F-4D97-AF65-F5344CB8AC3E}">
+        <p14:creationId xmlns:p14="http://schemas.microsoft.com/office/powerpoint/2010/main" val="577290024"/>
+      </p:ext>
+    </p:extLst>
+  </p:cSld>
+  <p:clrMapOvr>
+    <a:masterClrMapping/>
+  </p:clrMapOvr>
+</p:notes>
+</file>
+
+<file path=ppt/notesSlides/notesSlide8.xml><?xml version="1.0" encoding="utf-8"?>
+<p:notes xmlns:a="http://schemas.openxmlformats.org/drawingml/2006/main" xmlns:r="http://schemas.openxmlformats.org/officeDocument/2006/relationships" xmlns:p="http://schemas.openxmlformats.org/presentationml/2006/main">
+  <p:cSld>
+    <p:spTree>
+      <p:nvGrpSpPr>
+        <p:cNvPr id="1" name=""/>
+        <p:cNvGrpSpPr/>
+        <p:nvPr/>
+      </p:nvGrpSpPr>
+      <p:grpSpPr>
+        <a:xfrm>
+          <a:off x="0" y="0"/>
+          <a:ext cx="0" cy="0"/>
+          <a:chOff x="0" y="0"/>
+          <a:chExt cx="0" cy="0"/>
+        </a:xfrm>
+      </p:grpSpPr>
+      <p:sp>
+        <p:nvSpPr>
+          <p:cNvPr id="2" name="Slide Image Placeholder 1"/>
+          <p:cNvSpPr>
+            <a:spLocks noGrp="1" noRot="1" noChangeAspect="1"/>
+          </p:cNvSpPr>
+          <p:nvPr>
+            <p:ph type="sldImg"/>
+          </p:nvPr>
+        </p:nvSpPr>
+        <p:spPr/>
+      </p:sp>
+      <p:sp>
+        <p:nvSpPr>
+          <p:cNvPr id="3" name="Notes Placeholder 2"/>
+          <p:cNvSpPr>
+            <a:spLocks noGrp="1"/>
+          </p:cNvSpPr>
+          <p:nvPr>
+            <p:ph type="body" idx="1"/>
+          </p:nvPr>
+        </p:nvSpPr>
+        <p:spPr/>
+        <p:txBody>
+          <a:bodyPr/>
+          <a:lstStyle/>
+          <a:p>
+            <a:r>
+              <a:rPr lang="en-US" dirty="0"/>
+              <a:t>For customer analysis, We calculated Recency, Frequency, and Monetary value using the customer’s unique identifier. The results show that some customers placed many repeat orders, indicating a segment of loyal, high-value customers that could be targeted for retention programs.</a:t>
+            </a:r>
+          </a:p>
+        </p:txBody>
+      </p:sp>
+      <p:sp>
+        <p:nvSpPr>
+          <p:cNvPr id="4" name="Slide Number Placeholder 3"/>
+          <p:cNvSpPr>
+            <a:spLocks noGrp="1"/>
+          </p:cNvSpPr>
+          <p:nvPr>
+            <p:ph type="sldNum" sz="quarter" idx="5"/>
+          </p:nvPr>
+        </p:nvSpPr>
+        <p:spPr/>
+        <p:txBody>
+          <a:bodyPr/>
+          <a:lstStyle/>
+          <a:p>
+            <a:fld id="{BB5C6805-D20B-405F-86DA-DC495A4FC83C}" type="slidenum">
+              <a:rPr lang="en-US"/>
+              <a:t>8</a:t>
+            </a:fld>
+            <a:endParaRPr lang="en-US"/>
+          </a:p>
+        </p:txBody>
+      </p:sp>
+    </p:spTree>
+    <p:extLst>
+      <p:ext uri="{BB962C8B-B14F-4D97-AF65-F5344CB8AC3E}">
+        <p14:creationId xmlns:p14="http://schemas.microsoft.com/office/powerpoint/2010/main" val="2227343938"/>
+      </p:ext>
+    </p:extLst>
+  </p:cSld>
+  <p:clrMapOvr>
+    <a:masterClrMapping/>
+  </p:clrMapOvr>
+</p:notes>
+</file>
+
+<file path=ppt/notesSlides/notesSlide9.xml><?xml version="1.0" encoding="utf-8"?>
+<p:notes xmlns:a="http://schemas.openxmlformats.org/drawingml/2006/main" xmlns:r="http://schemas.openxmlformats.org/officeDocument/2006/relationships" xmlns:p="http://schemas.openxmlformats.org/presentationml/2006/main">
+  <p:cSld>
+    <p:spTree>
+      <p:nvGrpSpPr>
+        <p:cNvPr id="1" name=""/>
+        <p:cNvGrpSpPr/>
+        <p:nvPr/>
+      </p:nvGrpSpPr>
+      <p:grpSpPr>
+        <a:xfrm>
+          <a:off x="0" y="0"/>
+          <a:ext cx="0" cy="0"/>
+          <a:chOff x="0" y="0"/>
+          <a:chExt cx="0" cy="0"/>
+        </a:xfrm>
+      </p:grpSpPr>
+      <p:sp>
+        <p:nvSpPr>
+          <p:cNvPr id="2" name="Slide Image Placeholder 1"/>
+          <p:cNvSpPr>
+            <a:spLocks noGrp="1" noRot="1" noChangeAspect="1"/>
+          </p:cNvSpPr>
+          <p:nvPr>
+            <p:ph type="sldImg"/>
+          </p:nvPr>
+        </p:nvSpPr>
+        <p:spPr/>
+      </p:sp>
+      <p:sp>
+        <p:nvSpPr>
+          <p:cNvPr id="3" name="Notes Placeholder 2"/>
+          <p:cNvSpPr>
+            <a:spLocks noGrp="1"/>
+          </p:cNvSpPr>
+          <p:nvPr>
+            <p:ph type="body" idx="1"/>
+          </p:nvPr>
+        </p:nvSpPr>
+        <p:spPr/>
+        <p:txBody>
+          <a:bodyPr/>
+          <a:lstStyle/>
+          <a:p>
+            <a:r>
+              <a:rPr lang="en-US" dirty="0"/>
+              <a:t>In summary, this project demonstrates an end-to-end analytics engineering workflow using </a:t>
+            </a:r>
+            <a:r>
+              <a:rPr lang="en-US" dirty="0" err="1"/>
+              <a:t>DuckDB</a:t>
+            </a:r>
+            <a:r>
+              <a:rPr lang="en-US" dirty="0"/>
+              <a:t> and </a:t>
+            </a:r>
+            <a:r>
+              <a:rPr lang="en-US" dirty="0" err="1"/>
+              <a:t>dbt</a:t>
+            </a:r>
+            <a:r>
+              <a:rPr lang="en-US" dirty="0"/>
+              <a:t>. We learned how to design a star schema, implement automated data quality tests, and generate business insights from transactional data. Key findings include strong revenue growth, high-performing product categories, concentration of sales in São Paulo, and evidence of repeat customer behavior. </a:t>
+            </a:r>
+          </a:p>
+        </p:txBody>
+      </p:sp>
+      <p:sp>
+        <p:nvSpPr>
+          <p:cNvPr id="4" name="Slide Number Placeholder 3"/>
+          <p:cNvSpPr>
+            <a:spLocks noGrp="1"/>
+          </p:cNvSpPr>
+          <p:nvPr>
+            <p:ph type="sldNum" sz="quarter" idx="5"/>
+          </p:nvPr>
+        </p:nvSpPr>
+        <p:spPr/>
+        <p:txBody>
+          <a:bodyPr/>
+          <a:lstStyle/>
+          <a:p>
+            <a:fld id="{BB5C6805-D20B-405F-86DA-DC495A4FC83C}" type="slidenum">
+              <a:rPr lang="en-US"/>
+              <a:t>9</a:t>
+            </a:fld>
+            <a:endParaRPr lang="en-US"/>
+          </a:p>
+        </p:txBody>
+      </p:sp>
+    </p:spTree>
+    <p:extLst>
+      <p:ext uri="{BB962C8B-B14F-4D97-AF65-F5344CB8AC3E}">
+        <p14:creationId xmlns:p14="http://schemas.microsoft.com/office/powerpoint/2010/main" val="4072080152"/>
+      </p:ext>
+    </p:extLst>
+  </p:cSld>
+  <p:clrMapOvr>
+    <a:masterClrMapping/>
+  </p:clrMapOvr>
+</p:notes>
 </file>
 
 <file path=ppt/slideLayouts/slideLayout1.xml><?xml version="1.0" encoding="utf-8"?>
@@ -470,7 +1739,7 @@
             <a:fld id="{B61BEF0D-F0BB-DE4B-95CE-6DB70DBA9567}" type="datetimeFigureOut">
               <a:rPr lang="en-US" dirty="0"/>
               <a:pPr/>
-              <a:t>6/7/2026</a:t>
+              <a:t>6/8/2026</a:t>
             </a:fld>
             <a:endParaRPr lang="en-US" dirty="0"/>
           </a:p>
@@ -791,7 +2060,7 @@
             <a:fld id="{B61BEF0D-F0BB-DE4B-95CE-6DB70DBA9567}" type="datetimeFigureOut">
               <a:rPr lang="en-US" dirty="0"/>
               <a:pPr/>
-              <a:t>6/7/2026</a:t>
+              <a:t>6/8/2026</a:t>
             </a:fld>
             <a:endParaRPr lang="en-US" dirty="0"/>
           </a:p>
@@ -1040,7 +2309,7 @@
             <a:fld id="{B61BEF0D-F0BB-DE4B-95CE-6DB70DBA9567}" type="datetimeFigureOut">
               <a:rPr lang="en-US" dirty="0"/>
               <a:pPr/>
-              <a:t>6/7/2026</a:t>
+              <a:t>6/8/2026</a:t>
             </a:fld>
             <a:endParaRPr lang="en-US" dirty="0"/>
           </a:p>
@@ -1380,7 +2649,7 @@
             <a:fld id="{B61BEF0D-F0BB-DE4B-95CE-6DB70DBA9567}" type="datetimeFigureOut">
               <a:rPr lang="en-US" dirty="0"/>
               <a:pPr/>
-              <a:t>6/7/2026</a:t>
+              <a:t>6/8/2026</a:t>
             </a:fld>
             <a:endParaRPr lang="en-US" dirty="0"/>
           </a:p>
@@ -1728,7 +2997,7 @@
             <a:fld id="{B61BEF0D-F0BB-DE4B-95CE-6DB70DBA9567}" type="datetimeFigureOut">
               <a:rPr lang="en-US" dirty="0"/>
               <a:pPr/>
-              <a:t>6/7/2026</a:t>
+              <a:t>6/8/2026</a:t>
             </a:fld>
             <a:endParaRPr lang="en-US" dirty="0"/>
           </a:p>
@@ -2103,7 +3372,7 @@
             <a:fld id="{B61BEF0D-F0BB-DE4B-95CE-6DB70DBA9567}" type="datetimeFigureOut">
               <a:rPr lang="en-US" dirty="0"/>
               <a:pPr/>
-              <a:t>6/7/2026</a:t>
+              <a:t>6/8/2026</a:t>
             </a:fld>
             <a:endParaRPr lang="en-US" dirty="0"/>
           </a:p>
@@ -2574,7 +3843,7 @@
             <a:fld id="{B61BEF0D-F0BB-DE4B-95CE-6DB70DBA9567}" type="datetimeFigureOut">
               <a:rPr lang="en-US" dirty="0"/>
               <a:pPr/>
-              <a:t>6/7/2026</a:t>
+              <a:t>6/8/2026</a:t>
             </a:fld>
             <a:endParaRPr lang="en-US" dirty="0"/>
           </a:p>
@@ -2784,7 +4053,7 @@
             <a:fld id="{B61BEF0D-F0BB-DE4B-95CE-6DB70DBA9567}" type="datetimeFigureOut">
               <a:rPr lang="en-US" dirty="0"/>
               <a:pPr/>
-              <a:t>6/7/2026</a:t>
+              <a:t>6/8/2026</a:t>
             </a:fld>
             <a:endParaRPr lang="en-US" dirty="0"/>
           </a:p>
@@ -2995,7 +4264,7 @@
             <a:fld id="{B61BEF0D-F0BB-DE4B-95CE-6DB70DBA9567}" type="datetimeFigureOut">
               <a:rPr lang="en-US" dirty="0"/>
               <a:pPr/>
-              <a:t>6/7/2026</a:t>
+              <a:t>6/8/2026</a:t>
             </a:fld>
             <a:endParaRPr lang="en-US" dirty="0"/>
           </a:p>
@@ -3226,7 +4495,7 @@
           <a:p>
             <a:fld id="{05BFA754-D5C3-4E66-96A6-867B257F58DC}" type="datetimeFigureOut">
               <a:rPr lang="en-US" dirty="0"/>
-              <a:t>6/7/2026</a:t>
+              <a:t>6/8/2026</a:t>
             </a:fld>
             <a:endParaRPr lang="en-US" dirty="0"/>
           </a:p>
@@ -3474,7 +4743,7 @@
             <a:fld id="{B61BEF0D-F0BB-DE4B-95CE-6DB70DBA9567}" type="datetimeFigureOut">
               <a:rPr lang="en-US" dirty="0"/>
               <a:pPr/>
-              <a:t>6/7/2026</a:t>
+              <a:t>6/8/2026</a:t>
             </a:fld>
             <a:endParaRPr lang="en-US" dirty="0"/>
           </a:p>
@@ -3775,7 +5044,7 @@
           <a:p>
             <a:fld id="{05BFA754-D5C3-4E66-96A6-867B257F58DC}" type="datetimeFigureOut">
               <a:rPr lang="en-US" dirty="0"/>
-              <a:t>6/7/2026</a:t>
+              <a:t>6/8/2026</a:t>
             </a:fld>
             <a:endParaRPr lang="en-US" dirty="0"/>
           </a:p>
@@ -4155,7 +5424,7 @@
             <a:fld id="{B61BEF0D-F0BB-DE4B-95CE-6DB70DBA9567}" type="datetimeFigureOut">
               <a:rPr lang="en-US" dirty="0"/>
               <a:pPr/>
-              <a:t>6/7/2026</a:t>
+              <a:t>6/8/2026</a:t>
             </a:fld>
             <a:endParaRPr lang="en-US" dirty="0"/>
           </a:p>
@@ -4310,7 +5579,7 @@
             <a:fld id="{B61BEF0D-F0BB-DE4B-95CE-6DB70DBA9567}" type="datetimeFigureOut">
               <a:rPr lang="en-US" dirty="0"/>
               <a:pPr/>
-              <a:t>6/7/2026</a:t>
+              <a:t>6/8/2026</a:t>
             </a:fld>
             <a:endParaRPr lang="en-US" dirty="0"/>
           </a:p>
@@ -4438,7 +5707,7 @@
             <a:fld id="{B61BEF0D-F0BB-DE4B-95CE-6DB70DBA9567}" type="datetimeFigureOut">
               <a:rPr lang="en-US" dirty="0"/>
               <a:pPr/>
-              <a:t>6/7/2026</a:t>
+              <a:t>6/8/2026</a:t>
             </a:fld>
             <a:endParaRPr lang="en-US" dirty="0"/>
           </a:p>
@@ -4693,7 +5962,7 @@
             <a:fld id="{B61BEF0D-F0BB-DE4B-95CE-6DB70DBA9567}" type="datetimeFigureOut">
               <a:rPr lang="en-US" dirty="0"/>
               <a:pPr/>
-              <a:t>6/7/2026</a:t>
+              <a:t>6/8/2026</a:t>
             </a:fld>
             <a:endParaRPr lang="en-US" dirty="0"/>
           </a:p>
@@ -5004,7 +6273,7 @@
             <a:fld id="{B61BEF0D-F0BB-DE4B-95CE-6DB70DBA9567}" type="datetimeFigureOut">
               <a:rPr lang="en-US" dirty="0"/>
               <a:pPr/>
-              <a:t>6/7/2026</a:t>
+              <a:t>6/8/2026</a:t>
             </a:fld>
             <a:endParaRPr lang="en-US" dirty="0"/>
           </a:p>
@@ -5355,7 +6624,7 @@
             <a:fld id="{B61BEF0D-F0BB-DE4B-95CE-6DB70DBA9567}" type="datetimeFigureOut">
               <a:rPr lang="en-US" dirty="0"/>
               <a:pPr/>
-              <a:t>6/7/2026</a:t>
+              <a:t>6/8/2026</a:t>
             </a:fld>
             <a:endParaRPr lang="en-US" dirty="0"/>
           </a:p>
@@ -6085,6 +7354,296 @@
           </a:p>
         </p:txBody>
       </p:sp>
+      <p:sp>
+        <p:nvSpPr>
+          <p:cNvPr id="6" name="TextBox 5">
+            <a:extLst>
+              <a:ext uri="{FF2B5EF4-FFF2-40B4-BE49-F238E27FC236}">
+                <a16:creationId xmlns:a16="http://schemas.microsoft.com/office/drawing/2014/main" id="{04EF12ED-33EF-9957-3B97-7463A89DAB56}"/>
+              </a:ext>
+            </a:extLst>
+          </p:cNvPr>
+          <p:cNvSpPr txBox="1"/>
+          <p:nvPr/>
+        </p:nvSpPr>
+        <p:spPr>
+          <a:xfrm>
+            <a:off x="3909646" y="3845169"/>
+            <a:ext cx="1336431" cy="461665"/>
+          </a:xfrm>
+          <a:prstGeom prst="rect">
+            <a:avLst/>
+          </a:prstGeom>
+          <a:solidFill>
+            <a:schemeClr val="accent5">
+              <a:lumMod val="60000"/>
+              <a:lumOff val="40000"/>
+            </a:schemeClr>
+          </a:solidFill>
+        </p:spPr>
+        <p:txBody>
+          <a:bodyPr rot="0" spcFirstLastPara="0" vertOverflow="overflow" horzOverflow="overflow" vert="horz" wrap="square" lIns="91440" tIns="45720" rIns="91440" bIns="45720" numCol="1" spcCol="0" rtlCol="0" fromWordArt="0" anchor="t" anchorCtr="0" forceAA="0" compatLnSpc="1">
+            <a:prstTxWarp prst="textNoShape">
+              <a:avLst/>
+            </a:prstTxWarp>
+            <a:spAutoFit/>
+          </a:bodyPr>
+          <a:lstStyle/>
+          <a:p>
+            <a:pPr algn="l"/>
+            <a:r>
+              <a:rPr lang="en-US" sz="2400" dirty="0" err="1">
+                <a:solidFill>
+                  <a:srgbClr val="262626"/>
+                </a:solidFill>
+              </a:rPr>
+              <a:t>fact_sales</a:t>
+            </a:r>
+            <a:endParaRPr lang="en-US" dirty="0" err="1"/>
+          </a:p>
+        </p:txBody>
+      </p:sp>
+      <p:cxnSp>
+        <p:nvCxnSpPr>
+          <p:cNvPr id="7" name="Straight Arrow Connector 6">
+            <a:extLst>
+              <a:ext uri="{FF2B5EF4-FFF2-40B4-BE49-F238E27FC236}">
+                <a16:creationId xmlns:a16="http://schemas.microsoft.com/office/drawing/2014/main" id="{AC5512C5-C53E-14C9-4EF9-AA712CFA0101}"/>
+              </a:ext>
+            </a:extLst>
+          </p:cNvPr>
+          <p:cNvCxnSpPr/>
+          <p:nvPr/>
+        </p:nvCxnSpPr>
+        <p:spPr>
+          <a:xfrm>
+            <a:off x="5023338" y="4308230"/>
+            <a:ext cx="914400" cy="914400"/>
+          </a:xfrm>
+          <a:prstGeom prst="straightConnector1">
+            <a:avLst/>
+          </a:prstGeom>
+        </p:spPr>
+        <p:style>
+          <a:lnRef idx="1">
+            <a:schemeClr val="accent1"/>
+          </a:lnRef>
+          <a:fillRef idx="0">
+            <a:schemeClr val="accent1"/>
+          </a:fillRef>
+          <a:effectRef idx="0">
+            <a:schemeClr val="accent1"/>
+          </a:effectRef>
+          <a:fontRef idx="minor">
+            <a:schemeClr val="tx1"/>
+          </a:fontRef>
+        </p:style>
+      </p:cxnSp>
+      <p:cxnSp>
+        <p:nvCxnSpPr>
+          <p:cNvPr id="9" name="Straight Arrow Connector 8">
+            <a:extLst>
+              <a:ext uri="{FF2B5EF4-FFF2-40B4-BE49-F238E27FC236}">
+                <a16:creationId xmlns:a16="http://schemas.microsoft.com/office/drawing/2014/main" id="{3323F2A7-D149-A20A-C67B-63EE505FFF10}"/>
+              </a:ext>
+            </a:extLst>
+          </p:cNvPr>
+          <p:cNvCxnSpPr/>
+          <p:nvPr/>
+        </p:nvCxnSpPr>
+        <p:spPr>
+          <a:xfrm flipH="1">
+            <a:off x="3223846" y="4314091"/>
+            <a:ext cx="926123" cy="926124"/>
+          </a:xfrm>
+          <a:prstGeom prst="straightConnector1">
+            <a:avLst/>
+          </a:prstGeom>
+        </p:spPr>
+        <p:style>
+          <a:lnRef idx="1">
+            <a:schemeClr val="accent1"/>
+          </a:lnRef>
+          <a:fillRef idx="0">
+            <a:schemeClr val="accent1"/>
+          </a:fillRef>
+          <a:effectRef idx="0">
+            <a:schemeClr val="accent1"/>
+          </a:effectRef>
+          <a:fontRef idx="minor">
+            <a:schemeClr val="tx1"/>
+          </a:fontRef>
+        </p:style>
+      </p:cxnSp>
+      <p:cxnSp>
+        <p:nvCxnSpPr>
+          <p:cNvPr id="10" name="Straight Arrow Connector 9">
+            <a:extLst>
+              <a:ext uri="{FF2B5EF4-FFF2-40B4-BE49-F238E27FC236}">
+                <a16:creationId xmlns:a16="http://schemas.microsoft.com/office/drawing/2014/main" id="{EC5D17D2-6ECC-7755-BD96-903481ED9970}"/>
+              </a:ext>
+            </a:extLst>
+          </p:cNvPr>
+          <p:cNvCxnSpPr/>
+          <p:nvPr/>
+        </p:nvCxnSpPr>
+        <p:spPr>
+          <a:xfrm flipH="1">
+            <a:off x="4566138" y="4314092"/>
+            <a:ext cx="17584" cy="931984"/>
+          </a:xfrm>
+          <a:prstGeom prst="straightConnector1">
+            <a:avLst/>
+          </a:prstGeom>
+        </p:spPr>
+        <p:style>
+          <a:lnRef idx="1">
+            <a:schemeClr val="accent1"/>
+          </a:lnRef>
+          <a:fillRef idx="0">
+            <a:schemeClr val="accent1"/>
+          </a:fillRef>
+          <a:effectRef idx="0">
+            <a:schemeClr val="accent1"/>
+          </a:effectRef>
+          <a:fontRef idx="minor">
+            <a:schemeClr val="tx1"/>
+          </a:fontRef>
+        </p:style>
+      </p:cxnSp>
+      <p:sp>
+        <p:nvSpPr>
+          <p:cNvPr id="11" name="TextBox 10">
+            <a:extLst>
+              <a:ext uri="{FF2B5EF4-FFF2-40B4-BE49-F238E27FC236}">
+                <a16:creationId xmlns:a16="http://schemas.microsoft.com/office/drawing/2014/main" id="{23FF5A8C-374B-8EDF-352F-1397BC3928AC}"/>
+              </a:ext>
+            </a:extLst>
+          </p:cNvPr>
+          <p:cNvSpPr txBox="1"/>
+          <p:nvPr/>
+        </p:nvSpPr>
+        <p:spPr>
+          <a:xfrm>
+            <a:off x="2033953" y="5246076"/>
+            <a:ext cx="1500554" cy="369332"/>
+          </a:xfrm>
+          <a:prstGeom prst="rect">
+            <a:avLst/>
+          </a:prstGeom>
+          <a:solidFill>
+            <a:schemeClr val="accent5">
+              <a:lumMod val="60000"/>
+              <a:lumOff val="40000"/>
+            </a:schemeClr>
+          </a:solidFill>
+        </p:spPr>
+        <p:txBody>
+          <a:bodyPr rot="0" spcFirstLastPara="0" vertOverflow="overflow" horzOverflow="overflow" vert="horz" wrap="square" lIns="91440" tIns="45720" rIns="91440" bIns="45720" numCol="1" spcCol="0" rtlCol="0" fromWordArt="0" anchor="t" anchorCtr="0" forceAA="0" compatLnSpc="1">
+            <a:prstTxWarp prst="textNoShape">
+              <a:avLst/>
+            </a:prstTxWarp>
+            <a:spAutoFit/>
+          </a:bodyPr>
+          <a:lstStyle/>
+          <a:p>
+            <a:pPr algn="l"/>
+            <a:r>
+              <a:rPr lang="en-US" dirty="0" err="1"/>
+              <a:t>dim_customer</a:t>
+            </a:r>
+            <a:endParaRPr lang="en-US"/>
+          </a:p>
+        </p:txBody>
+      </p:sp>
+      <p:sp>
+        <p:nvSpPr>
+          <p:cNvPr id="12" name="TextBox 11">
+            <a:extLst>
+              <a:ext uri="{FF2B5EF4-FFF2-40B4-BE49-F238E27FC236}">
+                <a16:creationId xmlns:a16="http://schemas.microsoft.com/office/drawing/2014/main" id="{631376E8-905C-7EA0-3B85-AC1E4178D408}"/>
+              </a:ext>
+            </a:extLst>
+          </p:cNvPr>
+          <p:cNvSpPr txBox="1"/>
+          <p:nvPr/>
+        </p:nvSpPr>
+        <p:spPr>
+          <a:xfrm>
+            <a:off x="3745521" y="5246075"/>
+            <a:ext cx="1500554" cy="369332"/>
+          </a:xfrm>
+          <a:prstGeom prst="rect">
+            <a:avLst/>
+          </a:prstGeom>
+          <a:solidFill>
+            <a:schemeClr val="accent5">
+              <a:lumMod val="60000"/>
+              <a:lumOff val="40000"/>
+            </a:schemeClr>
+          </a:solidFill>
+        </p:spPr>
+        <p:txBody>
+          <a:bodyPr rot="0" spcFirstLastPara="0" vertOverflow="overflow" horzOverflow="overflow" vert="horz" wrap="square" lIns="91440" tIns="45720" rIns="91440" bIns="45720" numCol="1" spcCol="0" rtlCol="0" fromWordArt="0" anchor="t" anchorCtr="0" forceAA="0" compatLnSpc="1">
+            <a:prstTxWarp prst="textNoShape">
+              <a:avLst/>
+            </a:prstTxWarp>
+            <a:spAutoFit/>
+          </a:bodyPr>
+          <a:lstStyle/>
+          <a:p>
+            <a:pPr algn="l"/>
+            <a:r>
+              <a:rPr lang="en-US" dirty="0" err="1"/>
+              <a:t>dim_product</a:t>
+            </a:r>
+          </a:p>
+        </p:txBody>
+      </p:sp>
+      <p:sp>
+        <p:nvSpPr>
+          <p:cNvPr id="13" name="TextBox 12">
+            <a:extLst>
+              <a:ext uri="{FF2B5EF4-FFF2-40B4-BE49-F238E27FC236}">
+                <a16:creationId xmlns:a16="http://schemas.microsoft.com/office/drawing/2014/main" id="{01694F03-80DB-14BD-997A-67B2221B4F0F}"/>
+              </a:ext>
+            </a:extLst>
+          </p:cNvPr>
+          <p:cNvSpPr txBox="1"/>
+          <p:nvPr/>
+        </p:nvSpPr>
+        <p:spPr>
+          <a:xfrm>
+            <a:off x="5480537" y="5246075"/>
+            <a:ext cx="1500554" cy="369332"/>
+          </a:xfrm>
+          <a:prstGeom prst="rect">
+            <a:avLst/>
+          </a:prstGeom>
+          <a:solidFill>
+            <a:schemeClr val="accent5">
+              <a:lumMod val="60000"/>
+              <a:lumOff val="40000"/>
+            </a:schemeClr>
+          </a:solidFill>
+        </p:spPr>
+        <p:txBody>
+          <a:bodyPr rot="0" spcFirstLastPara="0" vertOverflow="overflow" horzOverflow="overflow" vert="horz" wrap="square" lIns="91440" tIns="45720" rIns="91440" bIns="45720" numCol="1" spcCol="0" rtlCol="0" fromWordArt="0" anchor="t" anchorCtr="0" forceAA="0" compatLnSpc="1">
+            <a:prstTxWarp prst="textNoShape">
+              <a:avLst/>
+            </a:prstTxWarp>
+            <a:spAutoFit/>
+          </a:bodyPr>
+          <a:lstStyle/>
+          <a:p>
+            <a:pPr algn="l"/>
+            <a:r>
+              <a:rPr lang="en-US" dirty="0" err="1"/>
+              <a:t>dim_seller</a:t>
+            </a:r>
+          </a:p>
+        </p:txBody>
+      </p:sp>
     </p:spTree>
   </p:cSld>
   <p:clrMapOvr>
@@ -6192,7 +7751,7 @@
           <p:nvPr/>
         </p:nvPicPr>
         <p:blipFill>
-          <a:blip r:embed="rId2"/>
+          <a:blip r:embed="rId3"/>
           <a:stretch>
             <a:fillRect/>
           </a:stretch>
@@ -6289,7 +7848,7 @@
           <p:nvPr/>
         </p:nvPicPr>
         <p:blipFill>
-          <a:blip r:embed="rId2"/>
+          <a:blip r:embed="rId3"/>
           <a:stretch>
             <a:fillRect/>
           </a:stretch>
@@ -6386,7 +7945,7 @@
           <p:nvPr/>
         </p:nvPicPr>
         <p:blipFill>
-          <a:blip r:embed="rId2"/>
+          <a:blip r:embed="rId3"/>
           <a:stretch>
             <a:fillRect/>
           </a:stretch>
@@ -6483,7 +8042,7 @@
           <p:nvPr/>
         </p:nvPicPr>
         <p:blipFill>
-          <a:blip r:embed="rId2"/>
+          <a:blip r:embed="rId3"/>
           <a:stretch>
             <a:fillRect/>
           </a:stretch>
@@ -6584,7 +8143,7 @@
           <p:nvPr/>
         </p:nvPicPr>
         <p:blipFill>
-          <a:blip r:embed="rId2"/>
+          <a:blip r:embed="rId3"/>
           <a:stretch>
             <a:fillRect/>
           </a:stretch>
@@ -6905,4 +8464,299 @@
     </a:ext>
   </a:extLst>
 </a:theme>
+</file>
+
+<file path=ppt/theme/theme2.xml><?xml version="1.0" encoding="utf-8"?>
+<a:theme xmlns:a="http://schemas.openxmlformats.org/drawingml/2006/main" name="Office Theme">
+  <a:themeElements>
+    <a:clrScheme name="Office">
+      <a:dk1>
+        <a:sysClr val="windowText" lastClr="000000"/>
+      </a:dk1>
+      <a:lt1>
+        <a:sysClr val="window" lastClr="FFFFFF"/>
+      </a:lt1>
+      <a:dk2>
+        <a:srgbClr val="44546A"/>
+      </a:dk2>
+      <a:lt2>
+        <a:srgbClr val="E7E6E6"/>
+      </a:lt2>
+      <a:accent1>
+        <a:srgbClr val="4472C4"/>
+      </a:accent1>
+      <a:accent2>
+        <a:srgbClr val="ED7D31"/>
+      </a:accent2>
+      <a:accent3>
+        <a:srgbClr val="A5A5A5"/>
+      </a:accent3>
+      <a:accent4>
+        <a:srgbClr val="FFC000"/>
+      </a:accent4>
+      <a:accent5>
+        <a:srgbClr val="5B9BD5"/>
+      </a:accent5>
+      <a:accent6>
+        <a:srgbClr val="70AD47"/>
+      </a:accent6>
+      <a:hlink>
+        <a:srgbClr val="0563C1"/>
+      </a:hlink>
+      <a:folHlink>
+        <a:srgbClr val="954F72"/>
+      </a:folHlink>
+    </a:clrScheme>
+    <a:fontScheme name="Office">
+      <a:majorFont>
+        <a:latin typeface="Calibri Light" panose="020F0302020204030204"/>
+        <a:ea typeface=""/>
+        <a:cs typeface=""/>
+        <a:font script="Jpan" typeface="游ゴシック Light"/>
+        <a:font script="Hang" typeface="맑은 고딕"/>
+        <a:font script="Hans" typeface="等线 Light"/>
+        <a:font script="Hant" typeface="新細明體"/>
+        <a:font script="Arab" typeface="Times New Roman"/>
+        <a:font script="Hebr" typeface="Times New Roman"/>
+        <a:font script="Thai" typeface="Angsana New"/>
+        <a:font script="Ethi" typeface="Nyala"/>
+        <a:font script="Beng" typeface="Vrinda"/>
+        <a:font script="Gujr" typeface="Shruti"/>
+        <a:font script="Khmr" typeface="MoolBoran"/>
+        <a:font script="Knda" typeface="Tunga"/>
+        <a:font script="Guru" typeface="Raavi"/>
+        <a:font script="Cans" typeface="Euphemia"/>
+        <a:font script="Cher" typeface="Plantagenet Cherokee"/>
+        <a:font script="Yiii" typeface="Microsoft Yi Baiti"/>
+        <a:font script="Tibt" typeface="Microsoft Himalaya"/>
+        <a:font script="Thaa" typeface="MV Boli"/>
+        <a:font script="Deva" typeface="Mangal"/>
+        <a:font script="Telu" typeface="Gautami"/>
+        <a:font script="Taml" typeface="Latha"/>
+        <a:font script="Syrc" typeface="Estrangelo Edessa"/>
+        <a:font script="Orya" typeface="Kalinga"/>
+        <a:font script="Mlym" typeface="Kartika"/>
+        <a:font script="Laoo" typeface="DokChampa"/>
+        <a:font script="Sinh" typeface="Iskoola Pota"/>
+        <a:font script="Mong" typeface="Mongolian Baiti"/>
+        <a:font script="Viet" typeface="Times New Roman"/>
+        <a:font script="Uigh" typeface="Microsoft Uighur"/>
+        <a:font script="Geor" typeface="Sylfaen"/>
+        <a:font script="Armn" typeface="Arial"/>
+        <a:font script="Bugi" typeface="Leelawadee UI"/>
+        <a:font script="Bopo" typeface="Microsoft JhengHei"/>
+        <a:font script="Java" typeface="Javanese Text"/>
+        <a:font script="Lisu" typeface="Segoe UI"/>
+        <a:font script="Mymr" typeface="Myanmar Text"/>
+        <a:font script="Nkoo" typeface="Ebrima"/>
+        <a:font script="Olck" typeface="Nirmala UI"/>
+        <a:font script="Osma" typeface="Ebrima"/>
+        <a:font script="Phag" typeface="Phagspa"/>
+        <a:font script="Syrn" typeface="Estrangelo Edessa"/>
+        <a:font script="Syrj" typeface="Estrangelo Edessa"/>
+        <a:font script="Syre" typeface="Estrangelo Edessa"/>
+        <a:font script="Sora" typeface="Nirmala UI"/>
+        <a:font script="Tale" typeface="Microsoft Tai Le"/>
+        <a:font script="Talu" typeface="Microsoft New Tai Lue"/>
+        <a:font script="Tfng" typeface="Ebrima"/>
+      </a:majorFont>
+      <a:minorFont>
+        <a:latin typeface="Calibri" panose="020F0502020204030204"/>
+        <a:ea typeface=""/>
+        <a:cs typeface=""/>
+        <a:font script="Jpan" typeface="游ゴシック"/>
+        <a:font script="Hang" typeface="맑은 고딕"/>
+        <a:font script="Hans" typeface="等线"/>
+        <a:font script="Hant" typeface="新細明體"/>
+        <a:font script="Arab" typeface="Arial"/>
+        <a:font script="Hebr" typeface="Arial"/>
+        <a:font script="Thai" typeface="Cordia New"/>
+        <a:font script="Ethi" typeface="Nyala"/>
+        <a:font script="Beng" typeface="Vrinda"/>
+        <a:font script="Gujr" typeface="Shruti"/>
+        <a:font script="Khmr" typeface="DaunPenh"/>
+        <a:font script="Knda" typeface="Tunga"/>
+        <a:font script="Guru" typeface="Raavi"/>
+        <a:font script="Cans" typeface="Euphemia"/>
+        <a:font script="Cher" typeface="Plantagenet Cherokee"/>
+        <a:font script="Yiii" typeface="Microsoft Yi Baiti"/>
+        <a:font script="Tibt" typeface="Microsoft Himalaya"/>
+        <a:font script="Thaa" typeface="MV Boli"/>
+        <a:font script="Deva" typeface="Mangal"/>
+        <a:font script="Telu" typeface="Gautami"/>
+        <a:font script="Taml" typeface="Latha"/>
+        <a:font script="Syrc" typeface="Estrangelo Edessa"/>
+        <a:font script="Orya" typeface="Kalinga"/>
+        <a:font script="Mlym" typeface="Kartika"/>
+        <a:font script="Laoo" typeface="DokChampa"/>
+        <a:font script="Sinh" typeface="Iskoola Pota"/>
+        <a:font script="Mong" typeface="Mongolian Baiti"/>
+        <a:font script="Viet" typeface="Arial"/>
+        <a:font script="Uigh" typeface="Microsoft Uighur"/>
+        <a:font script="Geor" typeface="Sylfaen"/>
+        <a:font script="Armn" typeface="Arial"/>
+        <a:font script="Bugi" typeface="Leelawadee UI"/>
+        <a:font script="Bopo" typeface="Microsoft JhengHei"/>
+        <a:font script="Java" typeface="Javanese Text"/>
+        <a:font script="Lisu" typeface="Segoe UI"/>
+        <a:font script="Mymr" typeface="Myanmar Text"/>
+        <a:font script="Nkoo" typeface="Ebrima"/>
+        <a:font script="Olck" typeface="Nirmala UI"/>
+        <a:font script="Osma" typeface="Ebrima"/>
+        <a:font script="Phag" typeface="Phagspa"/>
+        <a:font script="Syrn" typeface="Estrangelo Edessa"/>
+        <a:font script="Syrj" typeface="Estrangelo Edessa"/>
+        <a:font script="Syre" typeface="Estrangelo Edessa"/>
+        <a:font script="Sora" typeface="Nirmala UI"/>
+        <a:font script="Tale" typeface="Microsoft Tai Le"/>
+        <a:font script="Talu" typeface="Microsoft New Tai Lue"/>
+        <a:font script="Tfng" typeface="Ebrima"/>
+      </a:minorFont>
+    </a:fontScheme>
+    <a:fmtScheme name="Office">
+      <a:fillStyleLst>
+        <a:solidFill>
+          <a:schemeClr val="phClr"/>
+        </a:solidFill>
+        <a:gradFill rotWithShape="1">
+          <a:gsLst>
+            <a:gs pos="0">
+              <a:schemeClr val="phClr">
+                <a:lumMod val="110000"/>
+                <a:satMod val="105000"/>
+                <a:tint val="67000"/>
+              </a:schemeClr>
+            </a:gs>
+            <a:gs pos="50000">
+              <a:schemeClr val="phClr">
+                <a:lumMod val="105000"/>
+                <a:satMod val="103000"/>
+                <a:tint val="73000"/>
+              </a:schemeClr>
+            </a:gs>
+            <a:gs pos="100000">
+              <a:schemeClr val="phClr">
+                <a:lumMod val="105000"/>
+                <a:satMod val="109000"/>
+                <a:tint val="81000"/>
+              </a:schemeClr>
+            </a:gs>
+          </a:gsLst>
+          <a:lin ang="5400000" scaled="0"/>
+        </a:gradFill>
+        <a:gradFill rotWithShape="1">
+          <a:gsLst>
+            <a:gs pos="0">
+              <a:schemeClr val="phClr">
+                <a:satMod val="103000"/>
+                <a:lumMod val="102000"/>
+                <a:tint val="94000"/>
+              </a:schemeClr>
+            </a:gs>
+            <a:gs pos="50000">
+              <a:schemeClr val="phClr">
+                <a:satMod val="110000"/>
+                <a:lumMod val="100000"/>
+                <a:shade val="100000"/>
+              </a:schemeClr>
+            </a:gs>
+            <a:gs pos="100000">
+              <a:schemeClr val="phClr">
+                <a:lumMod val="99000"/>
+                <a:satMod val="120000"/>
+                <a:shade val="78000"/>
+              </a:schemeClr>
+            </a:gs>
+          </a:gsLst>
+          <a:lin ang="5400000" scaled="0"/>
+        </a:gradFill>
+      </a:fillStyleLst>
+      <a:lnStyleLst>
+        <a:ln w="6350" cap="flat" cmpd="sng" algn="ctr">
+          <a:solidFill>
+            <a:schemeClr val="phClr"/>
+          </a:solidFill>
+          <a:prstDash val="solid"/>
+          <a:miter lim="800000"/>
+        </a:ln>
+        <a:ln w="12700" cap="flat" cmpd="sng" algn="ctr">
+          <a:solidFill>
+            <a:schemeClr val="phClr"/>
+          </a:solidFill>
+          <a:prstDash val="solid"/>
+          <a:miter lim="800000"/>
+        </a:ln>
+        <a:ln w="19050" cap="flat" cmpd="sng" algn="ctr">
+          <a:solidFill>
+            <a:schemeClr val="phClr"/>
+          </a:solidFill>
+          <a:prstDash val="solid"/>
+          <a:miter lim="800000"/>
+        </a:ln>
+      </a:lnStyleLst>
+      <a:effectStyleLst>
+        <a:effectStyle>
+          <a:effectLst/>
+        </a:effectStyle>
+        <a:effectStyle>
+          <a:effectLst/>
+        </a:effectStyle>
+        <a:effectStyle>
+          <a:effectLst>
+            <a:outerShdw blurRad="57150" dist="19050" dir="5400000" algn="ctr" rotWithShape="0">
+              <a:srgbClr val="000000">
+                <a:alpha val="63000"/>
+              </a:srgbClr>
+            </a:outerShdw>
+          </a:effectLst>
+        </a:effectStyle>
+      </a:effectStyleLst>
+      <a:bgFillStyleLst>
+        <a:solidFill>
+          <a:schemeClr val="phClr"/>
+        </a:solidFill>
+        <a:solidFill>
+          <a:schemeClr val="phClr">
+            <a:tint val="95000"/>
+            <a:satMod val="170000"/>
+          </a:schemeClr>
+        </a:solidFill>
+        <a:gradFill rotWithShape="1">
+          <a:gsLst>
+            <a:gs pos="0">
+              <a:schemeClr val="phClr">
+                <a:tint val="93000"/>
+                <a:satMod val="150000"/>
+                <a:shade val="98000"/>
+                <a:lumMod val="102000"/>
+              </a:schemeClr>
+            </a:gs>
+            <a:gs pos="50000">
+              <a:schemeClr val="phClr">
+                <a:tint val="98000"/>
+                <a:satMod val="130000"/>
+                <a:shade val="90000"/>
+                <a:lumMod val="103000"/>
+              </a:schemeClr>
+            </a:gs>
+            <a:gs pos="100000">
+              <a:schemeClr val="phClr">
+                <a:shade val="63000"/>
+                <a:satMod val="120000"/>
+              </a:schemeClr>
+            </a:gs>
+          </a:gsLst>
+          <a:lin ang="5400000" scaled="0"/>
+        </a:gradFill>
+      </a:bgFillStyleLst>
+    </a:fmtScheme>
+  </a:themeElements>
+  <a:objectDefaults/>
+  <a:extraClrSchemeLst/>
+  <a:extLst>
+    <a:ext uri="{05A4C25C-085E-4340-85A3-A5531E510DB2}">
+      <thm15:themeFamily xmlns:thm15="http://schemas.microsoft.com/office/thememl/2012/main" name="Office Theme" id="{62F939B6-93AF-4DB8-9C6B-D6C7DFDC589F}" vid="{4A3C46E8-61CC-4603-A589-7422A47A8E4A}"/>
+    </a:ext>
+  </a:extLst>
+</a:theme>
 </file>
</xml_diff>

<commit_message>
Add more notes for presentation
</commit_message>
<xml_diff>
--- a/slices/Olist_Ecommerce_Project_Presentation.pptx
+++ b/slices/Olist_Ecommerce_Project_Presentation.pptx
@@ -703,9 +703,32 @@
             </a:r>
             <a:r>
               <a:rPr lang="en-US" dirty="0"/>
-              <a:t>.</a:t>
-            </a:r>
-            <a:endParaRPr lang="en-US"/>
+              <a:t>. We chose </a:t>
+            </a:r>
+            <a:r>
+              <a:rPr lang="en-US" dirty="0" err="1"/>
+              <a:t>dbt</a:t>
+            </a:r>
+            <a:r>
+              <a:rPr lang="en-US" dirty="0"/>
+              <a:t> because it follows analytics engineering best practices. It separates raw data from transformed business-ready models, makes transformations modular and reusable, provides built-in testing, and automatically documents data lineage. In our project, </a:t>
+            </a:r>
+            <a:r>
+              <a:rPr lang="en-US" dirty="0" err="1"/>
+              <a:t>dbt</a:t>
+            </a:r>
+            <a:r>
+              <a:rPr lang="en-US" dirty="0"/>
+              <a:t> helped us build a maintainable star schema on top of </a:t>
+            </a:r>
+            <a:r>
+              <a:rPr lang="en-US" dirty="0" err="1"/>
+              <a:t>DuckDB</a:t>
+            </a:r>
+            <a:r>
+              <a:rPr lang="en-US" dirty="0"/>
+              <a:t> while ensuring data quality through automated tests.</a:t>
+            </a:r>
           </a:p>
         </p:txBody>
       </p:sp>

</xml_diff>

<commit_message>
add names on slides
</commit_message>
<xml_diff>
--- a/slices/Olist_Ecommerce_Project_Presentation.pptx
+++ b/slices/Olist_Ecommerce_Project_Presentation.pptx
@@ -146,6 +146,7 @@
     <p1510:client id="{240DB585-72E7-41C7-B8B4-31166C77D257}" v="6" dt="2026-06-08T08:41:20.233"/>
     <p1510:client id="{A0EE111F-F56D-490A-9982-3577EAE95C08}" v="386" dt="2026-06-08T13:19:51.878"/>
     <p1510:client id="{D8EE50BA-8E0A-40EF-8C58-402B5C6725EB}" v="293" dt="2026-06-09T01:29:14.204"/>
+    <p1510:client id="{F492816E-2B29-46D8-B3B8-5ABAF1A79A35}" v="1" dt="2026-06-09T12:02:42.006"/>
   </p1510:revLst>
 </p1510:revInfo>
 </file>
@@ -231,7 +232,7 @@
           </a:lstStyle>
           <a:p>
             <a:fld id="{8DE1E0FE-415D-4A86-A5CB-56FB2301993F}" type="datetimeFigureOut">
-              <a:t>6/8/2026</a:t>
+              <a:t>6/9/2026</a:t>
             </a:fld>
             <a:endParaRPr lang="en-US"/>
           </a:p>
@@ -543,7 +544,7 @@
           <a:p>
             <a:r>
               <a:rPr lang="en-US" dirty="0"/>
-              <a:t>Huang Wei: Our project analyzes the Brazilian E-Commerce Public Dataset by </a:t>
+              <a:t>Pilo: Problem Statement &amp; Dataset: </a:t>
             </a:r>
             <a:r>
               <a:rPr lang="en-US" dirty="0" err="1"/>
@@ -551,6 +552,14 @@
             </a:r>
             <a:r>
               <a:rPr lang="en-US" dirty="0"/>
+              <a:t> is a Brazilian marketplace connecting sellers to customers across multiple channels. 9 source CSV files: orders, customers, products, sellers, order items, payments, reviews, geolocation. Business questions: how is revenue trending, which products perform best, who are the most valuable customers? Our project analyzes the Brazilian E-Commerce Public Dataset by </a:t>
+            </a:r>
+            <a:r>
+              <a:rPr lang="en-US" dirty="0" err="1"/>
+              <a:t>Olist</a:t>
+            </a:r>
+            <a:r>
+              <a:rPr lang="en-US" dirty="0"/>
               <a:t>. The goal was to build an end-to-end analytics workflow: load raw data into </a:t>
             </a:r>
             <a:r>
@@ -577,6 +586,10 @@
               <a:rPr lang="en-US" dirty="0"/>
               <a:t> tests, and then perform business analysis and visualization with Python and Pandas.</a:t>
             </a:r>
+            <a:endParaRPr lang="en-US">
+              <a:ea typeface="Calibri"/>
+              <a:cs typeface="Calibri"/>
+            </a:endParaRPr>
           </a:p>
         </p:txBody>
       </p:sp>
@@ -660,6 +673,13 @@
           <a:bodyPr/>
           <a:lstStyle/>
           <a:p>
+            <a:r>
+              <a:rPr lang="en-US">
+                <a:ea typeface="Calibri"/>
+                <a:cs typeface="Calibri"/>
+              </a:rPr>
+              <a:t>Jacky: </a:t>
+            </a:r>
             <a:endParaRPr lang="en-US" dirty="0"/>
           </a:p>
         </p:txBody>
@@ -746,7 +766,7 @@
           <a:p>
             <a:r>
               <a:rPr lang="en-US" dirty="0"/>
-              <a:t>This chart shows monthly revenue over time. Revenue generally increased during 2017 and 2018, indicating significant growth in the platform during the observed period. The trend also shows seasonal fluctuations, which are common in e-commerce businesses.</a:t>
+              <a:t>Sean: This chart shows monthly revenue over time. Revenue generally increased during 2017 and 2018, indicating significant growth in the platform during the observed period. The trend also shows seasonal fluctuations, which are common in e-commerce businesses.</a:t>
             </a:r>
           </a:p>
         </p:txBody>
@@ -833,7 +853,7 @@
           <a:p>
             <a:r>
               <a:rPr lang="en-US"/>
-              <a:t>The highest-revenue product categories were Beauty &amp; Health, Watches &amp; Gifts, and Bed, Bath &amp; Table. These categories contributed a large share of total revenue and could be prioritized for marketing and inventory planning.</a:t>
+              <a:t>Sean: The highest-revenue product categories were Beauty &amp; Health, Watches &amp; Gifts, and Bed, Bath &amp; Table. These categories contributed a large share of total revenue and could be prioritized for marketing and inventory planning.</a:t>
             </a:r>
           </a:p>
         </p:txBody>
@@ -920,7 +940,7 @@
           <a:p>
             <a:r>
               <a:rPr lang="en-US"/>
-              <a:t>Revenue was heavily concentrated in São Paulo (SP), followed by Rio de Janeiro and Minas Gerais. This suggests that customer demand is strongest in Brazil’s largest economic regions.</a:t>
+              <a:t>Sean: Revenue was heavily concentrated in São Paulo (SP), followed by Rio de Janeiro and Minas Gerais. This suggests that customer demand is strongest in Brazil’s largest economic regions.</a:t>
             </a:r>
           </a:p>
         </p:txBody>
@@ -1006,8 +1026,12 @@
           <a:lstStyle/>
           <a:p>
             <a:r>
+              <a:rPr lang="en-US"/>
+              <a:t>Annie: For</a:t>
+            </a:r>
+            <a:r>
               <a:rPr lang="en-US" dirty="0"/>
-              <a:t>For customer analysis, We calculated Recency, Frequency, and Monetary value using the customer’s unique identifier. The results show that some customers placed many repeat orders, indicating a segment of loyal, high-value customers that could be targeted for retention programs.</a:t>
+              <a:t> customer analysis, We calculated Recency, Frequency, and Monetary value using the customer’s unique identifier. The results show that some customers placed many repeat orders, indicating a segment of loyal, high-value customers that could be targeted for retention programs.</a:t>
             </a:r>
           </a:p>
         </p:txBody>
@@ -1094,7 +1118,7 @@
           <a:p>
             <a:r>
               <a:rPr lang="en-US" dirty="0"/>
-              <a:t>In summary, this project demonstrates an end-to-end analytics engineering workflow using </a:t>
+              <a:t>Michelle: In summary, this project demonstrates an end-to-end analytics engineering workflow using </a:t>
             </a:r>
             <a:r>
               <a:rPr lang="en-US" dirty="0" err="1"/>
@@ -1355,7 +1379,7 @@
           <a:p>
             <a:r>
               <a:rPr lang="en-US" dirty="0"/>
-              <a:t>The warehouse uses a star schema. The central fact table is </a:t>
+              <a:t>Dick: The warehouse uses a star schema. The central fact table is </a:t>
             </a:r>
             <a:r>
               <a:rPr lang="en-US" dirty="0" err="1"/>
@@ -1490,7 +1514,11 @@
               <a:defRPr/>
             </a:pPr>
             <a:r>
-              <a:rPr lang="en-US" sz="1200" i="1" kern="1200" dirty="0">
+              <a:rPr lang="en-US" i="1" dirty="0" err="1"/>
+              <a:t>Jacky</a:t>
+            </a:r>
+            <a:r>
+              <a:rPr lang="en-US" sz="1200" i="1" kern="1200" dirty="0" err="1">
                 <a:solidFill>
                   <a:schemeClr val="tx1"/>
                 </a:solidFill>
@@ -1499,7 +1527,19 @@
                 <a:ea typeface="+mn-ea"/>
                 <a:cs typeface="+mn-cs"/>
               </a:rPr>
-              <a:t>“My part of the project covers the data quality. The goal was to make sure the data feeding our dashboards and analysis is actually trustworthy — that primary keys are clean, relationships hold, and business rules like valid sales amounts are enforced. We will go through the two-layer approach used and what each layer catches.”</a:t>
+              <a:t>“My</a:t>
+            </a:r>
+            <a:r>
+              <a:rPr lang="en-US" sz="1200" i="1" kern="1200" dirty="0">
+                <a:solidFill>
+                  <a:schemeClr val="tx1"/>
+                </a:solidFill>
+                <a:effectLst/>
+                <a:latin typeface="+mn-lt"/>
+                <a:ea typeface="+mn-ea"/>
+                <a:cs typeface="+mn-cs"/>
+              </a:rPr>
+              <a:t> part of the project covers the data quality. The goal was to make sure the data feeding our dashboards and analysis is actually trustworthy — that primary keys are clean, relationships hold, and business rules like valid sales amounts are enforced. We will go through the two-layer approach used and what each layer catches.”</a:t>
             </a:r>
             <a:endParaRPr lang="en-US" sz="1200" kern="1200" dirty="0">
               <a:solidFill>
@@ -1596,6 +1636,13 @@
           <a:bodyPr/>
           <a:lstStyle/>
           <a:p>
+            <a:r>
+              <a:rPr lang="en-US">
+                <a:ea typeface="Calibri"/>
+                <a:cs typeface="Calibri"/>
+              </a:rPr>
+              <a:t>Jacky:</a:t>
+            </a:r>
             <a:endParaRPr lang="en-US" dirty="0"/>
           </a:p>
         </p:txBody>
@@ -1680,23 +1727,13 @@
           <a:bodyPr/>
           <a:lstStyle/>
           <a:p>
-            <a:pPr marL="0" marR="0" lvl="0" indent="0" algn="l" defTabSz="914400" rtl="0" eaLnBrk="1" fontAlgn="auto" latinLnBrk="0" hangingPunct="1">
-              <a:lnSpc>
-                <a:spcPct val="100000"/>
-              </a:lnSpc>
-              <a:spcBef>
-                <a:spcPts val="0"/>
-              </a:spcBef>
-              <a:spcAft>
-                <a:spcPts val="0"/>
-              </a:spcAft>
-              <a:buClrTx/>
-              <a:buSzTx/>
-              <a:buFontTx/>
-              <a:buNone/>
-              <a:tabLst/>
+            <a:pPr>
               <a:defRPr/>
             </a:pPr>
+            <a:r>
+              <a:rPr lang="en-US" i="1" dirty="0"/>
+              <a:t>Jacky: “</a:t>
+            </a:r>
             <a:r>
               <a:rPr lang="en-US" sz="1200" i="1" kern="1200" dirty="0">
                 <a:solidFill>
@@ -1707,7 +1744,7 @@
                 <a:ea typeface="+mn-ea"/>
                 <a:cs typeface="+mn-cs"/>
               </a:rPr>
-              <a:t>“The first layer uses </a:t>
+              <a:t>The first layer uses </a:t>
             </a:r>
             <a:r>
               <a:rPr lang="en-US" sz="1200" i="1" kern="1200" dirty="0" err="1">
@@ -1755,7 +1792,31 @@
                 <a:ea typeface="+mn-ea"/>
                 <a:cs typeface="+mn-cs"/>
               </a:rPr>
-              <a:t> — applied to the primary keys of all three dimension tables and the fact table. In total, 7 tests, and all 7 passed.”</a:t>
+              <a:t> — applied to the primary keys of all </a:t>
+            </a:r>
+            <a:r>
+              <a:rPr lang="en-US" sz="1200" i="1" kern="1200" dirty="0" err="1">
+                <a:solidFill>
+                  <a:schemeClr val="tx1"/>
+                </a:solidFill>
+                <a:effectLst/>
+                <a:latin typeface="+mn-lt"/>
+                <a:ea typeface="+mn-ea"/>
+                <a:cs typeface="+mn-cs"/>
+              </a:rPr>
+              <a:t>three dimension</a:t>
+            </a:r>
+            <a:r>
+              <a:rPr lang="en-US" sz="1200" i="1" kern="1200" dirty="0">
+                <a:solidFill>
+                  <a:schemeClr val="tx1"/>
+                </a:solidFill>
+                <a:effectLst/>
+                <a:latin typeface="+mn-lt"/>
+                <a:ea typeface="+mn-ea"/>
+                <a:cs typeface="+mn-cs"/>
+              </a:rPr>
+              <a:t> tables and the fact table. In total, 7 tests, and all 7 passed.”</a:t>
             </a:r>
             <a:endParaRPr lang="en-US" sz="1200" kern="1200" dirty="0">
               <a:solidFill>
@@ -1852,23 +1913,13 @@
           <a:bodyPr/>
           <a:lstStyle/>
           <a:p>
-            <a:pPr marL="0" marR="0" lvl="0" indent="0" algn="l" defTabSz="914400" rtl="0" eaLnBrk="1" fontAlgn="auto" latinLnBrk="0" hangingPunct="1">
-              <a:lnSpc>
-                <a:spcPct val="100000"/>
-              </a:lnSpc>
-              <a:spcBef>
-                <a:spcPts val="0"/>
-              </a:spcBef>
-              <a:spcAft>
-                <a:spcPts val="0"/>
-              </a:spcAft>
-              <a:buClrTx/>
-              <a:buSzTx/>
-              <a:buFontTx/>
-              <a:buNone/>
-              <a:tabLst/>
+            <a:pPr>
               <a:defRPr/>
             </a:pPr>
+            <a:r>
+              <a:rPr lang="en-US" i="1" dirty="0"/>
+              <a:t>Jacky: “</a:t>
+            </a:r>
             <a:r>
               <a:rPr lang="en-US" sz="1200" i="1" kern="1200" dirty="0">
                 <a:solidFill>
@@ -1879,7 +1930,7 @@
                 <a:ea typeface="+mn-ea"/>
                 <a:cs typeface="+mn-cs"/>
               </a:rPr>
-              <a:t>“The second layer goes beyond structure.  Here a Python script called data_quality.py runs four additional SQL checks directly against </a:t>
+              <a:t>The second layer goes beyond structure.  Here a Python script called data_quality.py runs four additional SQL checks directly against </a:t>
             </a:r>
             <a:r>
               <a:rPr lang="en-US" sz="1200" i="1" kern="1200" dirty="0" err="1">
@@ -2024,23 +2075,13 @@
           <a:bodyPr/>
           <a:lstStyle/>
           <a:p>
-            <a:pPr marL="0" marR="0" lvl="0" indent="0" algn="l" defTabSz="914400" rtl="0" eaLnBrk="1" fontAlgn="auto" latinLnBrk="0" hangingPunct="1">
-              <a:lnSpc>
-                <a:spcPct val="100000"/>
-              </a:lnSpc>
-              <a:spcBef>
-                <a:spcPts val="0"/>
-              </a:spcBef>
-              <a:spcAft>
-                <a:spcPts val="0"/>
-              </a:spcAft>
-              <a:buClrTx/>
-              <a:buSzTx/>
-              <a:buFontTx/>
-              <a:buNone/>
-              <a:tabLst/>
+            <a:pPr>
               <a:defRPr/>
             </a:pPr>
+            <a:r>
+              <a:rPr lang="en-US" dirty="0"/>
+              <a:t>Jacky: The</a:t>
+            </a:r>
             <a:r>
               <a:rPr lang="en-US" sz="1200" kern="1200" dirty="0">
                 <a:solidFill>
@@ -2051,31 +2092,7 @@
                 <a:ea typeface="+mn-ea"/>
                 <a:cs typeface="+mn-cs"/>
               </a:rPr>
-              <a:t>The script stores each check’s name and SQL in a </a:t>
-            </a:r>
-            <a:r>
-              <a:rPr lang="en-US" sz="1200" kern="1200">
-                <a:solidFill>
-                  <a:schemeClr val="tx1"/>
-                </a:solidFill>
-                <a:effectLst/>
-                <a:latin typeface="+mn-lt"/>
-                <a:ea typeface="+mn-ea"/>
-                <a:cs typeface="+mn-cs"/>
-              </a:rPr>
-              <a:t>Python dictionary, </a:t>
-            </a:r>
-            <a:r>
-              <a:rPr lang="en-US" sz="1200" kern="1200" dirty="0">
-                <a:solidFill>
-                  <a:schemeClr val="tx1"/>
-                </a:solidFill>
-                <a:effectLst/>
-                <a:latin typeface="+mn-lt"/>
-                <a:ea typeface="+mn-ea"/>
-                <a:cs typeface="+mn-cs"/>
-              </a:rPr>
-              <a:t>then loops through them — running each query against </a:t>
+              <a:t> script stores each check’s name and SQL in a Python dictionary, then loops through them — running each query against </a:t>
             </a:r>
             <a:r>
               <a:rPr lang="en-US" sz="1200" kern="1200" dirty="0" err="1">
@@ -2187,23 +2204,13 @@
           <a:bodyPr/>
           <a:lstStyle/>
           <a:p>
-            <a:pPr marL="0" marR="0" lvl="0" indent="0" algn="l" defTabSz="914400" rtl="0" eaLnBrk="1" fontAlgn="auto" latinLnBrk="0" hangingPunct="1">
-              <a:lnSpc>
-                <a:spcPct val="100000"/>
-              </a:lnSpc>
-              <a:spcBef>
-                <a:spcPts val="0"/>
-              </a:spcBef>
-              <a:spcAft>
-                <a:spcPts val="0"/>
-              </a:spcAft>
-              <a:buClrTx/>
-              <a:buSzTx/>
-              <a:buFontTx/>
-              <a:buNone/>
-              <a:tabLst/>
+            <a:pPr>
               <a:defRPr/>
             </a:pPr>
+            <a:r>
+              <a:rPr lang="en-US" i="1" dirty="0"/>
+              <a:t>Jacky: </a:t>
+            </a:r>
             <a:r>
               <a:rPr lang="en-US" sz="1200" i="1" kern="1200" dirty="0">
                 <a:solidFill>
@@ -2671,7 +2678,7 @@
             <a:fld id="{B61BEF0D-F0BB-DE4B-95CE-6DB70DBA9567}" type="datetimeFigureOut">
               <a:rPr lang="en-US" dirty="0"/>
               <a:pPr/>
-              <a:t>6/8/2026</a:t>
+              <a:t>6/9/2026</a:t>
             </a:fld>
             <a:endParaRPr lang="en-US" dirty="0"/>
           </a:p>
@@ -2934,7 +2941,7 @@
             <a:fld id="{B61BEF0D-F0BB-DE4B-95CE-6DB70DBA9567}" type="datetimeFigureOut">
               <a:rPr lang="en-US" dirty="0"/>
               <a:pPr/>
-              <a:t>6/8/2026</a:t>
+              <a:t>6/9/2026</a:t>
             </a:fld>
             <a:endParaRPr lang="en-US" dirty="0"/>
           </a:p>
@@ -3185,7 +3192,7 @@
             <a:fld id="{B61BEF0D-F0BB-DE4B-95CE-6DB70DBA9567}" type="datetimeFigureOut">
               <a:rPr lang="en-US" dirty="0"/>
               <a:pPr/>
-              <a:t>6/8/2026</a:t>
+              <a:t>6/9/2026</a:t>
             </a:fld>
             <a:endParaRPr lang="en-US" dirty="0"/>
           </a:p>
@@ -3494,7 +3501,7 @@
             <a:fld id="{B61BEF0D-F0BB-DE4B-95CE-6DB70DBA9567}" type="datetimeFigureOut">
               <a:rPr lang="en-US" dirty="0"/>
               <a:pPr/>
-              <a:t>6/8/2026</a:t>
+              <a:t>6/9/2026</a:t>
             </a:fld>
             <a:endParaRPr lang="en-US" dirty="0"/>
           </a:p>
@@ -3813,7 +3820,7 @@
             <a:fld id="{B61BEF0D-F0BB-DE4B-95CE-6DB70DBA9567}" type="datetimeFigureOut">
               <a:rPr lang="en-US" dirty="0"/>
               <a:pPr/>
-              <a:t>6/8/2026</a:t>
+              <a:t>6/9/2026</a:t>
             </a:fld>
             <a:endParaRPr lang="en-US" dirty="0"/>
           </a:p>
@@ -4116,7 +4123,7 @@
             <a:fld id="{B61BEF0D-F0BB-DE4B-95CE-6DB70DBA9567}" type="datetimeFigureOut">
               <a:rPr lang="en-US" dirty="0"/>
               <a:pPr/>
-              <a:t>6/8/2026</a:t>
+              <a:t>6/9/2026</a:t>
             </a:fld>
             <a:endParaRPr lang="en-US" dirty="0"/>
           </a:p>
@@ -4484,7 +4491,7 @@
             <a:fld id="{B61BEF0D-F0BB-DE4B-95CE-6DB70DBA9567}" type="datetimeFigureOut">
               <a:rPr lang="en-US" dirty="0"/>
               <a:pPr/>
-              <a:t>6/8/2026</a:t>
+              <a:t>6/9/2026</a:t>
             </a:fld>
             <a:endParaRPr lang="en-US" dirty="0"/>
           </a:p>
@@ -4670,7 +4677,7 @@
             <a:fld id="{B61BEF0D-F0BB-DE4B-95CE-6DB70DBA9567}" type="datetimeFigureOut">
               <a:rPr lang="en-US" dirty="0"/>
               <a:pPr/>
-              <a:t>6/8/2026</a:t>
+              <a:t>6/9/2026</a:t>
             </a:fld>
             <a:endParaRPr lang="en-US" dirty="0"/>
           </a:p>
@@ -4856,7 +4863,7 @@
             <a:fld id="{B61BEF0D-F0BB-DE4B-95CE-6DB70DBA9567}" type="datetimeFigureOut">
               <a:rPr lang="en-US" dirty="0"/>
               <a:pPr/>
-              <a:t>6/8/2026</a:t>
+              <a:t>6/9/2026</a:t>
             </a:fld>
             <a:endParaRPr lang="en-US" dirty="0"/>
           </a:p>
@@ -5071,7 +5078,7 @@
             <a:fld id="{B61BEF0D-F0BB-DE4B-95CE-6DB70DBA9567}" type="datetimeFigureOut">
               <a:rPr lang="en-US" dirty="0"/>
               <a:pPr/>
-              <a:t>6/8/2026</a:t>
+              <a:t>6/9/2026</a:t>
             </a:fld>
             <a:endParaRPr lang="en-US" dirty="0"/>
           </a:p>
@@ -5322,7 +5329,7 @@
             <a:fld id="{B61BEF0D-F0BB-DE4B-95CE-6DB70DBA9567}" type="datetimeFigureOut">
               <a:rPr lang="en-US" dirty="0"/>
               <a:pPr/>
-              <a:t>6/8/2026</a:t>
+              <a:t>6/9/2026</a:t>
             </a:fld>
             <a:endParaRPr lang="en-US" dirty="0"/>
           </a:p>
@@ -5568,7 +5575,7 @@
             <a:fld id="{B61BEF0D-F0BB-DE4B-95CE-6DB70DBA9567}" type="datetimeFigureOut">
               <a:rPr lang="en-US" dirty="0"/>
               <a:pPr/>
-              <a:t>6/8/2026</a:t>
+              <a:t>6/9/2026</a:t>
             </a:fld>
             <a:endParaRPr lang="en-US" dirty="0"/>
           </a:p>
@@ -5956,7 +5963,7 @@
             <a:fld id="{B61BEF0D-F0BB-DE4B-95CE-6DB70DBA9567}" type="datetimeFigureOut">
               <a:rPr lang="en-US" dirty="0"/>
               <a:pPr/>
-              <a:t>6/8/2026</a:t>
+              <a:t>6/9/2026</a:t>
             </a:fld>
             <a:endParaRPr lang="en-US" dirty="0"/>
           </a:p>
@@ -6086,7 +6093,7 @@
             <a:fld id="{B61BEF0D-F0BB-DE4B-95CE-6DB70DBA9567}" type="datetimeFigureOut">
               <a:rPr lang="en-US" dirty="0"/>
               <a:pPr/>
-              <a:t>6/8/2026</a:t>
+              <a:t>6/9/2026</a:t>
             </a:fld>
             <a:endParaRPr lang="en-US" dirty="0"/>
           </a:p>
@@ -6183,7 +6190,7 @@
             <a:fld id="{B61BEF0D-F0BB-DE4B-95CE-6DB70DBA9567}" type="datetimeFigureOut">
               <a:rPr lang="en-US" dirty="0"/>
               <a:pPr/>
-              <a:t>6/8/2026</a:t>
+              <a:t>6/9/2026</a:t>
             </a:fld>
             <a:endParaRPr lang="en-US" dirty="0"/>
           </a:p>
@@ -6438,7 +6445,7 @@
             <a:fld id="{B61BEF0D-F0BB-DE4B-95CE-6DB70DBA9567}" type="datetimeFigureOut">
               <a:rPr lang="en-US" dirty="0"/>
               <a:pPr/>
-              <a:t>6/8/2026</a:t>
+              <a:t>6/9/2026</a:t>
             </a:fld>
             <a:endParaRPr lang="en-US" dirty="0"/>
           </a:p>
@@ -6718,7 +6725,7 @@
             <a:fld id="{B61BEF0D-F0BB-DE4B-95CE-6DB70DBA9567}" type="datetimeFigureOut">
               <a:rPr lang="en-US" dirty="0"/>
               <a:pPr/>
-              <a:t>6/8/2026</a:t>
+              <a:t>6/9/2026</a:t>
             </a:fld>
             <a:endParaRPr lang="en-US" dirty="0"/>
           </a:p>
@@ -7129,7 +7136,7 @@
             <a:fld id="{B61BEF0D-F0BB-DE4B-95CE-6DB70DBA9567}" type="datetimeFigureOut">
               <a:rPr lang="en-US" dirty="0"/>
               <a:pPr/>
-              <a:t>6/8/2026</a:t>
+              <a:t>6/9/2026</a:t>
             </a:fld>
             <a:endParaRPr lang="en-US" dirty="0"/>
           </a:p>

</xml_diff>